<commit_message>
uploaded updated milestone file
</commit_message>
<xml_diff>
--- a/Milestone Files/Milestone 4/Milestone4 Presentation.pptx
+++ b/Milestone Files/Milestone 4/Milestone4 Presentation.pptx
@@ -2455,7 +2455,7 @@
         </p:nvSpPr>
         <p:spPr>
           <a:xfrm>
-            <a:off x="502920" y="365760"/>
+            <a:off x="502920" y="382386"/>
             <a:ext cx="11155680" cy="640080"/>
           </a:xfrm>
           <a:prstGeom prst="rect">
@@ -5096,7 +5096,7 @@
         </p:nvSpPr>
         <p:spPr>
           <a:xfrm>
-            <a:off x="502920" y="960120"/>
+            <a:off x="502920" y="968433"/>
             <a:ext cx="10972800" cy="320040"/>
           </a:xfrm>
           <a:prstGeom prst="rect">
@@ -5631,7 +5631,7 @@
         </p:nvSpPr>
         <p:spPr>
           <a:xfrm>
-            <a:off x="6766560" y="1508760"/>
+            <a:off x="6766560" y="2011680"/>
             <a:ext cx="4892040" cy="4846320"/>
           </a:xfrm>
           <a:prstGeom prst="roundRect">
@@ -10305,7 +10305,7 @@
         </p:nvSpPr>
         <p:spPr>
           <a:xfrm>
-            <a:off x="6309360" y="1417320"/>
+            <a:off x="6263640" y="1296785"/>
             <a:ext cx="5349240" cy="4937760"/>
           </a:xfrm>
           <a:prstGeom prst="roundRect">
@@ -10323,6 +10323,13 @@
             <a:prstDash val="solid"/>
           </a:ln>
         </p:spPr>
+        <p:txBody>
+          <a:bodyPr/>
+          <a:lstStyle/>
+          <a:p>
+            <a:endParaRPr lang="en-IN" dirty="0"/>
+          </a:p>
+        </p:txBody>
       </p:sp>
       <p:sp>
         <p:nvSpPr>
@@ -10357,7 +10364,7 @@
                 <a:ea typeface="Calibri" pitchFamily="34" charset="-122"/>
                 <a:cs typeface="Calibri" pitchFamily="34" charset="-120"/>
               </a:rPr>
-              <a:t>QUALITATIVE SAMPLE — H5N1 QA PASSAGE</a:t>
+              <a:t>QUALITATIVE SAMPLE</a:t>
             </a:r>
             <a:endParaRPr lang="en-US" sz="1200" dirty="0"/>
           </a:p>
@@ -10384,11 +10391,25 @@
           <a:bodyPr wrap="square" rtlCol="0" anchor="t"/>
           <a:lstStyle/>
           <a:p>
-            <a:pPr marL="0" indent="0">
+            <a:pPr>
               <a:lnSpc>
                 <a:spcPct val="110000"/>
               </a:lnSpc>
-              <a:buNone/>
+            </a:pPr>
+            <a:endParaRPr lang="en-US" sz="1050" b="1" dirty="0">
+              <a:solidFill>
+                <a:srgbClr val="1E2761"/>
+              </a:solidFill>
+              <a:latin typeface="Calibri" pitchFamily="34" charset="0"/>
+              <a:ea typeface="Calibri" pitchFamily="34" charset="-122"/>
+              <a:cs typeface="Calibri" pitchFamily="34" charset="-120"/>
+            </a:endParaRPr>
+          </a:p>
+          <a:p>
+            <a:pPr>
+              <a:lnSpc>
+                <a:spcPct val="110000"/>
+              </a:lnSpc>
             </a:pPr>
             <a:r>
               <a:rPr lang="en-US" sz="1050" b="1" dirty="0">
@@ -10399,20 +10420,681 @@
                 <a:ea typeface="Calibri" pitchFamily="34" charset="-122"/>
                 <a:cs typeface="Calibri" pitchFamily="34" charset="-120"/>
               </a:rPr>
-              <a:t>Question: </a:t>
-            </a:r>
-            <a:r>
-              <a:rPr lang="en-US" sz="1050" i="1" dirty="0">
-                <a:solidFill>
-                  <a:srgbClr val="1E2761"/>
-                </a:solidFill>
-                <a:latin typeface="Calibri" pitchFamily="34" charset="0"/>
-                <a:ea typeface="Calibri" pitchFamily="34" charset="-122"/>
-                <a:cs typeface="Calibri" pitchFamily="34" charset="-120"/>
-              </a:rPr>
-              <a:t>What did US scientists confirm about the H5N1 virus, and how has the risk to humans increased?</a:t>
-            </a:r>
-            <a:endParaRPr lang="en-US" sz="1050" dirty="0"/>
+              <a:t>Question:</a:t>
+            </a:r>
+            <a:r>
+              <a:rPr lang="en-IN" sz="1100" dirty="0" err="1">
+                <a:ln w="0"/>
+                <a:solidFill>
+                  <a:schemeClr val="accent1"/>
+                </a:solidFill>
+                <a:effectLst>
+                  <a:outerShdw blurRad="38100" dist="25400" dir="5400000" algn="ctr" rotWithShape="0">
+                    <a:srgbClr val="6E747A">
+                      <a:alpha val="43000"/>
+                    </a:srgbClr>
+                  </a:outerShdw>
+                </a:effectLst>
+              </a:rPr>
+              <a:t>अमरीकी</a:t>
+            </a:r>
+            <a:r>
+              <a:rPr lang="en-IN" sz="1100" dirty="0">
+                <a:ln w="0"/>
+                <a:solidFill>
+                  <a:schemeClr val="accent1"/>
+                </a:solidFill>
+                <a:effectLst>
+                  <a:outerShdw blurRad="38100" dist="25400" dir="5400000" algn="ctr" rotWithShape="0">
+                    <a:srgbClr val="6E747A">
+                      <a:alpha val="43000"/>
+                    </a:srgbClr>
+                  </a:outerShdw>
+                </a:effectLst>
+              </a:rPr>
+              <a:t> </a:t>
+            </a:r>
+            <a:r>
+              <a:rPr lang="en-IN" sz="1100" dirty="0" err="1">
+                <a:ln w="0"/>
+                <a:solidFill>
+                  <a:schemeClr val="accent1"/>
+                </a:solidFill>
+                <a:effectLst>
+                  <a:outerShdw blurRad="38100" dist="25400" dir="5400000" algn="ctr" rotWithShape="0">
+                    <a:srgbClr val="6E747A">
+                      <a:alpha val="43000"/>
+                    </a:srgbClr>
+                  </a:outerShdw>
+                </a:effectLst>
+              </a:rPr>
+              <a:t>वैज्ञानिकों</a:t>
+            </a:r>
+            <a:r>
+              <a:rPr lang="en-IN" sz="1100" dirty="0">
+                <a:ln w="0"/>
+                <a:solidFill>
+                  <a:schemeClr val="accent1"/>
+                </a:solidFill>
+                <a:effectLst>
+                  <a:outerShdw blurRad="38100" dist="25400" dir="5400000" algn="ctr" rotWithShape="0">
+                    <a:srgbClr val="6E747A">
+                      <a:alpha val="43000"/>
+                    </a:srgbClr>
+                  </a:outerShdw>
+                </a:effectLst>
+              </a:rPr>
+              <a:t> </a:t>
+            </a:r>
+            <a:r>
+              <a:rPr lang="en-IN" sz="1100" dirty="0" err="1">
+                <a:ln w="0"/>
+                <a:solidFill>
+                  <a:schemeClr val="accent1"/>
+                </a:solidFill>
+                <a:effectLst>
+                  <a:outerShdw blurRad="38100" dist="25400" dir="5400000" algn="ctr" rotWithShape="0">
+                    <a:srgbClr val="6E747A">
+                      <a:alpha val="43000"/>
+                    </a:srgbClr>
+                  </a:outerShdw>
+                </a:effectLst>
+              </a:rPr>
+              <a:t>ने</a:t>
+            </a:r>
+            <a:r>
+              <a:rPr lang="en-IN" sz="1100" dirty="0">
+                <a:ln w="0"/>
+                <a:solidFill>
+                  <a:schemeClr val="accent1"/>
+                </a:solidFill>
+                <a:effectLst>
+                  <a:outerShdw blurRad="38100" dist="25400" dir="5400000" algn="ctr" rotWithShape="0">
+                    <a:srgbClr val="6E747A">
+                      <a:alpha val="43000"/>
+                    </a:srgbClr>
+                  </a:outerShdw>
+                </a:effectLst>
+              </a:rPr>
+              <a:t> एच5एन1 </a:t>
+            </a:r>
+            <a:r>
+              <a:rPr lang="en-IN" sz="1100" dirty="0" err="1">
+                <a:ln w="0"/>
+                <a:solidFill>
+                  <a:schemeClr val="accent1"/>
+                </a:solidFill>
+                <a:effectLst>
+                  <a:outerShdw blurRad="38100" dist="25400" dir="5400000" algn="ctr" rotWithShape="0">
+                    <a:srgbClr val="6E747A">
+                      <a:alpha val="43000"/>
+                    </a:srgbClr>
+                  </a:outerShdw>
+                </a:effectLst>
+              </a:rPr>
+              <a:t>वायरस</a:t>
+            </a:r>
+            <a:r>
+              <a:rPr lang="en-IN" sz="1100" dirty="0">
+                <a:ln w="0"/>
+                <a:solidFill>
+                  <a:schemeClr val="accent1"/>
+                </a:solidFill>
+                <a:effectLst>
+                  <a:outerShdw blurRad="38100" dist="25400" dir="5400000" algn="ctr" rotWithShape="0">
+                    <a:srgbClr val="6E747A">
+                      <a:alpha val="43000"/>
+                    </a:srgbClr>
+                  </a:outerShdw>
+                </a:effectLst>
+              </a:rPr>
+              <a:t> </a:t>
+            </a:r>
+            <a:r>
+              <a:rPr lang="en-IN" sz="1100" dirty="0" err="1">
+                <a:ln w="0"/>
+                <a:solidFill>
+                  <a:schemeClr val="accent1"/>
+                </a:solidFill>
+                <a:effectLst>
+                  <a:outerShdw blurRad="38100" dist="25400" dir="5400000" algn="ctr" rotWithShape="0">
+                    <a:srgbClr val="6E747A">
+                      <a:alpha val="43000"/>
+                    </a:srgbClr>
+                  </a:outerShdw>
+                </a:effectLst>
+              </a:rPr>
+              <a:t>के</a:t>
+            </a:r>
+            <a:r>
+              <a:rPr lang="en-IN" sz="1100" dirty="0">
+                <a:ln w="0"/>
+                <a:solidFill>
+                  <a:schemeClr val="accent1"/>
+                </a:solidFill>
+                <a:effectLst>
+                  <a:outerShdw blurRad="38100" dist="25400" dir="5400000" algn="ctr" rotWithShape="0">
+                    <a:srgbClr val="6E747A">
+                      <a:alpha val="43000"/>
+                    </a:srgbClr>
+                  </a:outerShdw>
+                </a:effectLst>
+              </a:rPr>
+              <a:t> </a:t>
+            </a:r>
+            <a:r>
+              <a:rPr lang="en-IN" sz="1100" dirty="0" err="1">
+                <a:ln w="0"/>
+                <a:solidFill>
+                  <a:schemeClr val="accent1"/>
+                </a:solidFill>
+                <a:effectLst>
+                  <a:outerShdw blurRad="38100" dist="25400" dir="5400000" algn="ctr" rotWithShape="0">
+                    <a:srgbClr val="6E747A">
+                      <a:alpha val="43000"/>
+                    </a:srgbClr>
+                  </a:outerShdw>
+                </a:effectLst>
+              </a:rPr>
+              <a:t>बारे</a:t>
+            </a:r>
+            <a:r>
+              <a:rPr lang="en-IN" sz="1100" dirty="0">
+                <a:ln w="0"/>
+                <a:solidFill>
+                  <a:schemeClr val="accent1"/>
+                </a:solidFill>
+                <a:effectLst>
+                  <a:outerShdw blurRad="38100" dist="25400" dir="5400000" algn="ctr" rotWithShape="0">
+                    <a:srgbClr val="6E747A">
+                      <a:alpha val="43000"/>
+                    </a:srgbClr>
+                  </a:outerShdw>
+                </a:effectLst>
+              </a:rPr>
+              <a:t> </a:t>
+            </a:r>
+            <a:r>
+              <a:rPr lang="en-IN" sz="1100" dirty="0" err="1">
+                <a:ln w="0"/>
+                <a:solidFill>
+                  <a:schemeClr val="accent1"/>
+                </a:solidFill>
+                <a:effectLst>
+                  <a:outerShdw blurRad="38100" dist="25400" dir="5400000" algn="ctr" rotWithShape="0">
+                    <a:srgbClr val="6E747A">
+                      <a:alpha val="43000"/>
+                    </a:srgbClr>
+                  </a:outerShdw>
+                </a:effectLst>
+              </a:rPr>
+              <a:t>में</a:t>
+            </a:r>
+            <a:r>
+              <a:rPr lang="en-IN" sz="1100" dirty="0">
+                <a:ln w="0"/>
+                <a:solidFill>
+                  <a:schemeClr val="accent1"/>
+                </a:solidFill>
+                <a:effectLst>
+                  <a:outerShdw blurRad="38100" dist="25400" dir="5400000" algn="ctr" rotWithShape="0">
+                    <a:srgbClr val="6E747A">
+                      <a:alpha val="43000"/>
+                    </a:srgbClr>
+                  </a:outerShdw>
+                </a:effectLst>
+              </a:rPr>
+              <a:t> </a:t>
+            </a:r>
+            <a:r>
+              <a:rPr lang="en-IN" sz="1100" dirty="0" err="1">
+                <a:ln w="0"/>
+                <a:solidFill>
+                  <a:schemeClr val="accent1"/>
+                </a:solidFill>
+                <a:effectLst>
+                  <a:outerShdw blurRad="38100" dist="25400" dir="5400000" algn="ctr" rotWithShape="0">
+                    <a:srgbClr val="6E747A">
+                      <a:alpha val="43000"/>
+                    </a:srgbClr>
+                  </a:outerShdw>
+                </a:effectLst>
+              </a:rPr>
+              <a:t>क्या</a:t>
+            </a:r>
+            <a:r>
+              <a:rPr lang="en-IN" sz="1100" dirty="0">
+                <a:ln w="0"/>
+                <a:solidFill>
+                  <a:schemeClr val="accent1"/>
+                </a:solidFill>
+                <a:effectLst>
+                  <a:outerShdw blurRad="38100" dist="25400" dir="5400000" algn="ctr" rotWithShape="0">
+                    <a:srgbClr val="6E747A">
+                      <a:alpha val="43000"/>
+                    </a:srgbClr>
+                  </a:outerShdw>
+                </a:effectLst>
+              </a:rPr>
+              <a:t> </a:t>
+            </a:r>
+            <a:r>
+              <a:rPr lang="en-IN" sz="1100" dirty="0" err="1">
+                <a:ln w="0"/>
+                <a:solidFill>
+                  <a:schemeClr val="accent1"/>
+                </a:solidFill>
+                <a:effectLst>
+                  <a:outerShdw blurRad="38100" dist="25400" dir="5400000" algn="ctr" rotWithShape="0">
+                    <a:srgbClr val="6E747A">
+                      <a:alpha val="43000"/>
+                    </a:srgbClr>
+                  </a:outerShdw>
+                </a:effectLst>
+              </a:rPr>
+              <a:t>पुष्टि</a:t>
+            </a:r>
+            <a:r>
+              <a:rPr lang="en-IN" sz="1100" dirty="0">
+                <a:ln w="0"/>
+                <a:solidFill>
+                  <a:schemeClr val="accent1"/>
+                </a:solidFill>
+                <a:effectLst>
+                  <a:outerShdw blurRad="38100" dist="25400" dir="5400000" algn="ctr" rotWithShape="0">
+                    <a:srgbClr val="6E747A">
+                      <a:alpha val="43000"/>
+                    </a:srgbClr>
+                  </a:outerShdw>
+                </a:effectLst>
+              </a:rPr>
+              <a:t> </a:t>
+            </a:r>
+            <a:r>
+              <a:rPr lang="en-IN" sz="1100" dirty="0" err="1">
+                <a:ln w="0"/>
+                <a:solidFill>
+                  <a:schemeClr val="accent1"/>
+                </a:solidFill>
+                <a:effectLst>
+                  <a:outerShdw blurRad="38100" dist="25400" dir="5400000" algn="ctr" rotWithShape="0">
+                    <a:srgbClr val="6E747A">
+                      <a:alpha val="43000"/>
+                    </a:srgbClr>
+                  </a:outerShdw>
+                </a:effectLst>
+              </a:rPr>
+              <a:t>की</a:t>
+            </a:r>
+            <a:r>
+              <a:rPr lang="en-IN" sz="1100" dirty="0">
+                <a:ln w="0"/>
+                <a:solidFill>
+                  <a:schemeClr val="accent1"/>
+                </a:solidFill>
+                <a:effectLst>
+                  <a:outerShdw blurRad="38100" dist="25400" dir="5400000" algn="ctr" rotWithShape="0">
+                    <a:srgbClr val="6E747A">
+                      <a:alpha val="43000"/>
+                    </a:srgbClr>
+                  </a:outerShdw>
+                </a:effectLst>
+              </a:rPr>
+              <a:t> </a:t>
+            </a:r>
+            <a:r>
+              <a:rPr lang="en-IN" sz="1100" dirty="0" err="1">
+                <a:ln w="0"/>
+                <a:solidFill>
+                  <a:schemeClr val="accent1"/>
+                </a:solidFill>
+                <a:effectLst>
+                  <a:outerShdw blurRad="38100" dist="25400" dir="5400000" algn="ctr" rotWithShape="0">
+                    <a:srgbClr val="6E747A">
+                      <a:alpha val="43000"/>
+                    </a:srgbClr>
+                  </a:outerShdw>
+                </a:effectLst>
+              </a:rPr>
+              <a:t>है</a:t>
+            </a:r>
+            <a:r>
+              <a:rPr lang="en-IN" sz="1100" dirty="0">
+                <a:ln w="0"/>
+                <a:solidFill>
+                  <a:schemeClr val="accent1"/>
+                </a:solidFill>
+                <a:effectLst>
+                  <a:outerShdw blurRad="38100" dist="25400" dir="5400000" algn="ctr" rotWithShape="0">
+                    <a:srgbClr val="6E747A">
+                      <a:alpha val="43000"/>
+                    </a:srgbClr>
+                  </a:outerShdw>
+                </a:effectLst>
+              </a:rPr>
+              <a:t> </a:t>
+            </a:r>
+            <a:r>
+              <a:rPr lang="en-IN" sz="1100" dirty="0" err="1">
+                <a:ln w="0"/>
+                <a:solidFill>
+                  <a:schemeClr val="accent1"/>
+                </a:solidFill>
+                <a:effectLst>
+                  <a:outerShdw blurRad="38100" dist="25400" dir="5400000" algn="ctr" rotWithShape="0">
+                    <a:srgbClr val="6E747A">
+                      <a:alpha val="43000"/>
+                    </a:srgbClr>
+                  </a:outerShdw>
+                </a:effectLst>
+              </a:rPr>
+              <a:t>और</a:t>
+            </a:r>
+            <a:r>
+              <a:rPr lang="en-IN" sz="1100" dirty="0">
+                <a:ln w="0"/>
+                <a:solidFill>
+                  <a:schemeClr val="accent1"/>
+                </a:solidFill>
+                <a:effectLst>
+                  <a:outerShdw blurRad="38100" dist="25400" dir="5400000" algn="ctr" rotWithShape="0">
+                    <a:srgbClr val="6E747A">
+                      <a:alpha val="43000"/>
+                    </a:srgbClr>
+                  </a:outerShdw>
+                </a:effectLst>
+              </a:rPr>
+              <a:t> </a:t>
+            </a:r>
+            <a:r>
+              <a:rPr lang="en-IN" sz="1100" dirty="0" err="1">
+                <a:ln w="0"/>
+                <a:solidFill>
+                  <a:schemeClr val="accent1"/>
+                </a:solidFill>
+                <a:effectLst>
+                  <a:outerShdw blurRad="38100" dist="25400" dir="5400000" algn="ctr" rotWithShape="0">
+                    <a:srgbClr val="6E747A">
+                      <a:alpha val="43000"/>
+                    </a:srgbClr>
+                  </a:outerShdw>
+                </a:effectLst>
+              </a:rPr>
+              <a:t>इससे</a:t>
+            </a:r>
+            <a:r>
+              <a:rPr lang="en-IN" sz="1100" dirty="0">
+                <a:ln w="0"/>
+                <a:solidFill>
+                  <a:schemeClr val="accent1"/>
+                </a:solidFill>
+                <a:effectLst>
+                  <a:outerShdw blurRad="38100" dist="25400" dir="5400000" algn="ctr" rotWithShape="0">
+                    <a:srgbClr val="6E747A">
+                      <a:alpha val="43000"/>
+                    </a:srgbClr>
+                  </a:outerShdw>
+                </a:effectLst>
+              </a:rPr>
+              <a:t> </a:t>
+            </a:r>
+            <a:r>
+              <a:rPr lang="en-IN" sz="1100" dirty="0" err="1">
+                <a:ln w="0"/>
+                <a:solidFill>
+                  <a:schemeClr val="accent1"/>
+                </a:solidFill>
+                <a:effectLst>
+                  <a:outerShdw blurRad="38100" dist="25400" dir="5400000" algn="ctr" rotWithShape="0">
+                    <a:srgbClr val="6E747A">
+                      <a:alpha val="43000"/>
+                    </a:srgbClr>
+                  </a:outerShdw>
+                </a:effectLst>
+              </a:rPr>
+              <a:t>मनुष्यों</a:t>
+            </a:r>
+            <a:r>
+              <a:rPr lang="en-IN" sz="1100" dirty="0">
+                <a:ln w="0"/>
+                <a:solidFill>
+                  <a:schemeClr val="accent1"/>
+                </a:solidFill>
+                <a:effectLst>
+                  <a:outerShdw blurRad="38100" dist="25400" dir="5400000" algn="ctr" rotWithShape="0">
+                    <a:srgbClr val="6E747A">
+                      <a:alpha val="43000"/>
+                    </a:srgbClr>
+                  </a:outerShdw>
+                </a:effectLst>
+              </a:rPr>
+              <a:t> </a:t>
+            </a:r>
+            <a:r>
+              <a:rPr lang="en-IN" sz="1100" dirty="0" err="1">
+                <a:ln w="0"/>
+                <a:solidFill>
+                  <a:schemeClr val="accent1"/>
+                </a:solidFill>
+                <a:effectLst>
+                  <a:outerShdw blurRad="38100" dist="25400" dir="5400000" algn="ctr" rotWithShape="0">
+                    <a:srgbClr val="6E747A">
+                      <a:alpha val="43000"/>
+                    </a:srgbClr>
+                  </a:outerShdw>
+                </a:effectLst>
+              </a:rPr>
+              <a:t>के</a:t>
+            </a:r>
+            <a:r>
+              <a:rPr lang="en-IN" sz="1100" dirty="0">
+                <a:ln w="0"/>
+                <a:solidFill>
+                  <a:schemeClr val="accent1"/>
+                </a:solidFill>
+                <a:effectLst>
+                  <a:outerShdw blurRad="38100" dist="25400" dir="5400000" algn="ctr" rotWithShape="0">
+                    <a:srgbClr val="6E747A">
+                      <a:alpha val="43000"/>
+                    </a:srgbClr>
+                  </a:outerShdw>
+                </a:effectLst>
+              </a:rPr>
+              <a:t> </a:t>
+            </a:r>
+            <a:r>
+              <a:rPr lang="en-IN" sz="1100" dirty="0" err="1">
+                <a:ln w="0"/>
+                <a:solidFill>
+                  <a:schemeClr val="accent1"/>
+                </a:solidFill>
+                <a:effectLst>
+                  <a:outerShdw blurRad="38100" dist="25400" dir="5400000" algn="ctr" rotWithShape="0">
+                    <a:srgbClr val="6E747A">
+                      <a:alpha val="43000"/>
+                    </a:srgbClr>
+                  </a:outerShdw>
+                </a:effectLst>
+              </a:rPr>
+              <a:t>लिए</a:t>
+            </a:r>
+            <a:r>
+              <a:rPr lang="en-IN" sz="1100" dirty="0">
+                <a:ln w="0"/>
+                <a:solidFill>
+                  <a:schemeClr val="accent1"/>
+                </a:solidFill>
+                <a:effectLst>
+                  <a:outerShdw blurRad="38100" dist="25400" dir="5400000" algn="ctr" rotWithShape="0">
+                    <a:srgbClr val="6E747A">
+                      <a:alpha val="43000"/>
+                    </a:srgbClr>
+                  </a:outerShdw>
+                </a:effectLst>
+              </a:rPr>
+              <a:t> </a:t>
+            </a:r>
+            <a:r>
+              <a:rPr lang="en-IN" sz="1100" dirty="0" err="1">
+                <a:ln w="0"/>
+                <a:solidFill>
+                  <a:schemeClr val="accent1"/>
+                </a:solidFill>
+                <a:effectLst>
+                  <a:outerShdw blurRad="38100" dist="25400" dir="5400000" algn="ctr" rotWithShape="0">
+                    <a:srgbClr val="6E747A">
+                      <a:alpha val="43000"/>
+                    </a:srgbClr>
+                  </a:outerShdw>
+                </a:effectLst>
+              </a:rPr>
+              <a:t>क्या</a:t>
+            </a:r>
+            <a:r>
+              <a:rPr lang="en-IN" sz="1100" dirty="0">
+                <a:ln w="0"/>
+                <a:solidFill>
+                  <a:schemeClr val="accent1"/>
+                </a:solidFill>
+                <a:effectLst>
+                  <a:outerShdw blurRad="38100" dist="25400" dir="5400000" algn="ctr" rotWithShape="0">
+                    <a:srgbClr val="6E747A">
+                      <a:alpha val="43000"/>
+                    </a:srgbClr>
+                  </a:outerShdw>
+                </a:effectLst>
+              </a:rPr>
+              <a:t> </a:t>
+            </a:r>
+            <a:r>
+              <a:rPr lang="en-IN" sz="1100" dirty="0" err="1">
+                <a:ln w="0"/>
+                <a:solidFill>
+                  <a:schemeClr val="accent1"/>
+                </a:solidFill>
+                <a:effectLst>
+                  <a:outerShdw blurRad="38100" dist="25400" dir="5400000" algn="ctr" rotWithShape="0">
+                    <a:srgbClr val="6E747A">
+                      <a:alpha val="43000"/>
+                    </a:srgbClr>
+                  </a:outerShdw>
+                </a:effectLst>
+              </a:rPr>
+              <a:t>खतरा</a:t>
+            </a:r>
+            <a:r>
+              <a:rPr lang="en-IN" sz="1100" dirty="0">
+                <a:ln w="0"/>
+                <a:solidFill>
+                  <a:schemeClr val="accent1"/>
+                </a:solidFill>
+                <a:effectLst>
+                  <a:outerShdw blurRad="38100" dist="25400" dir="5400000" algn="ctr" rotWithShape="0">
+                    <a:srgbClr val="6E747A">
+                      <a:alpha val="43000"/>
+                    </a:srgbClr>
+                  </a:outerShdw>
+                </a:effectLst>
+              </a:rPr>
+              <a:t> </a:t>
+            </a:r>
+            <a:r>
+              <a:rPr lang="en-IN" sz="1100" dirty="0" err="1">
+                <a:ln w="0"/>
+                <a:solidFill>
+                  <a:schemeClr val="accent1"/>
+                </a:solidFill>
+                <a:effectLst>
+                  <a:outerShdw blurRad="38100" dist="25400" dir="5400000" algn="ctr" rotWithShape="0">
+                    <a:srgbClr val="6E747A">
+                      <a:alpha val="43000"/>
+                    </a:srgbClr>
+                  </a:outerShdw>
+                </a:effectLst>
+              </a:rPr>
+              <a:t>बढ़</a:t>
+            </a:r>
+            <a:r>
+              <a:rPr lang="en-IN" sz="1100" dirty="0">
+                <a:ln w="0"/>
+                <a:solidFill>
+                  <a:schemeClr val="accent1"/>
+                </a:solidFill>
+                <a:effectLst>
+                  <a:outerShdw blurRad="38100" dist="25400" dir="5400000" algn="ctr" rotWithShape="0">
+                    <a:srgbClr val="6E747A">
+                      <a:alpha val="43000"/>
+                    </a:srgbClr>
+                  </a:outerShdw>
+                </a:effectLst>
+              </a:rPr>
+              <a:t> </a:t>
+            </a:r>
+            <a:r>
+              <a:rPr lang="en-IN" sz="1100" dirty="0" err="1">
+                <a:ln w="0"/>
+                <a:solidFill>
+                  <a:schemeClr val="accent1"/>
+                </a:solidFill>
+                <a:effectLst>
+                  <a:outerShdw blurRad="38100" dist="25400" dir="5400000" algn="ctr" rotWithShape="0">
+                    <a:srgbClr val="6E747A">
+                      <a:alpha val="43000"/>
+                    </a:srgbClr>
+                  </a:outerShdw>
+                </a:effectLst>
+              </a:rPr>
+              <a:t>गया</a:t>
+            </a:r>
+            <a:r>
+              <a:rPr lang="en-IN" sz="1100" dirty="0">
+                <a:ln w="0"/>
+                <a:solidFill>
+                  <a:schemeClr val="accent1"/>
+                </a:solidFill>
+                <a:effectLst>
+                  <a:outerShdw blurRad="38100" dist="25400" dir="5400000" algn="ctr" rotWithShape="0">
+                    <a:srgbClr val="6E747A">
+                      <a:alpha val="43000"/>
+                    </a:srgbClr>
+                  </a:outerShdw>
+                </a:effectLst>
+              </a:rPr>
+              <a:t> </a:t>
+            </a:r>
+            <a:r>
+              <a:rPr lang="en-IN" sz="1100" dirty="0" err="1">
+                <a:ln w="0"/>
+                <a:solidFill>
+                  <a:schemeClr val="accent1"/>
+                </a:solidFill>
+                <a:effectLst>
+                  <a:outerShdw blurRad="38100" dist="25400" dir="5400000" algn="ctr" rotWithShape="0">
+                    <a:srgbClr val="6E747A">
+                      <a:alpha val="43000"/>
+                    </a:srgbClr>
+                  </a:outerShdw>
+                </a:effectLst>
+              </a:rPr>
+              <a:t>है</a:t>
+            </a:r>
+            <a:r>
+              <a:rPr lang="en-IN" sz="1100" dirty="0">
+                <a:ln w="0"/>
+                <a:solidFill>
+                  <a:schemeClr val="accent1"/>
+                </a:solidFill>
+                <a:effectLst>
+                  <a:outerShdw blurRad="38100" dist="25400" dir="5400000" algn="ctr" rotWithShape="0">
+                    <a:srgbClr val="6E747A">
+                      <a:alpha val="43000"/>
+                    </a:srgbClr>
+                  </a:outerShdw>
+                </a:effectLst>
+              </a:rPr>
+              <a:t>?</a:t>
+            </a:r>
+            <a:endParaRPr lang="en-US" sz="1100" dirty="0"/>
           </a:p>
         </p:txBody>
       </p:sp>
@@ -10424,7 +11106,7 @@
         </p:nvSpPr>
         <p:spPr>
           <a:xfrm>
-            <a:off x="6583680" y="2697480"/>
+            <a:off x="6583680" y="3176709"/>
             <a:ext cx="4846320" cy="1417320"/>
           </a:xfrm>
           <a:prstGeom prst="roundRect">
@@ -10446,7 +11128,7 @@
         </p:nvSpPr>
         <p:spPr>
           <a:xfrm>
-            <a:off x="6720840" y="2788920"/>
+            <a:off x="6720840" y="3313037"/>
             <a:ext cx="4572000" cy="1234440"/>
           </a:xfrm>
           <a:prstGeom prst="rect">
@@ -10459,14 +11141,13 @@
           <a:bodyPr wrap="square" rtlCol="0" anchor="t"/>
           <a:lstStyle/>
           <a:p>
-            <a:pPr marL="0" indent="0">
+            <a:pPr>
               <a:lnSpc>
                 <a:spcPct val="110000"/>
               </a:lnSpc>
-              <a:buNone/>
             </a:pPr>
             <a:r>
-              <a:rPr lang="en-US" sz="950" dirty="0">
+              <a:rPr lang="en-US" sz="1000" dirty="0">
                 <a:solidFill>
                   <a:srgbClr val="1E2761"/>
                 </a:solidFill>
@@ -10474,9 +11155,2076 @@
                 <a:ea typeface="Calibri" pitchFamily="34" charset="-122"/>
                 <a:cs typeface="Calibri" pitchFamily="34" charset="-120"/>
               </a:rPr>
-              <a:t>Original passage (76 tokens): WHO reported new bird-flu deaths in Azerbaijan; of 11 symptomatic cases since February, 5 died. US scientists confirmed the H5N1 virus split into two distinct strains, raising human risk.</a:t>
-            </a:r>
-            <a:endParaRPr lang="en-US" sz="950" dirty="0"/>
+              <a:t>Original passage(76 tokens):</a:t>
+            </a:r>
+            <a:r>
+              <a:rPr lang="en-US" sz="1000" dirty="0">
+                <a:ln w="0"/>
+                <a:solidFill>
+                  <a:schemeClr val="accent1"/>
+                </a:solidFill>
+                <a:effectLst>
+                  <a:outerShdw blurRad="38100" dist="25400" dir="5400000" algn="ctr" rotWithShape="0">
+                    <a:srgbClr val="6E747A">
+                      <a:alpha val="43000"/>
+                    </a:srgbClr>
+                  </a:outerShdw>
+                </a:effectLst>
+                <a:latin typeface="Calibri" pitchFamily="34" charset="0"/>
+                <a:ea typeface="Calibri" pitchFamily="34" charset="-122"/>
+                <a:cs typeface="Calibri" pitchFamily="34" charset="-120"/>
+              </a:rPr>
+              <a:t> </a:t>
+            </a:r>
+            <a:r>
+              <a:rPr lang="en-IN" sz="1000" dirty="0" err="1">
+                <a:ln w="0"/>
+                <a:solidFill>
+                  <a:schemeClr val="accent1"/>
+                </a:solidFill>
+                <a:effectLst>
+                  <a:outerShdw blurRad="38100" dist="25400" dir="5400000" algn="ctr" rotWithShape="0">
+                    <a:srgbClr val="6E747A">
+                      <a:alpha val="43000"/>
+                    </a:srgbClr>
+                  </a:outerShdw>
+                </a:effectLst>
+              </a:rPr>
+              <a:t>विश्व</a:t>
+            </a:r>
+            <a:r>
+              <a:rPr lang="en-IN" sz="1000" dirty="0">
+                <a:ln w="0"/>
+                <a:solidFill>
+                  <a:schemeClr val="accent1"/>
+                </a:solidFill>
+                <a:effectLst>
+                  <a:outerShdw blurRad="38100" dist="25400" dir="5400000" algn="ctr" rotWithShape="0">
+                    <a:srgbClr val="6E747A">
+                      <a:alpha val="43000"/>
+                    </a:srgbClr>
+                  </a:outerShdw>
+                </a:effectLst>
+              </a:rPr>
+              <a:t> </a:t>
+            </a:r>
+            <a:r>
+              <a:rPr lang="en-IN" sz="1000" dirty="0" err="1">
+                <a:ln w="0"/>
+                <a:solidFill>
+                  <a:schemeClr val="accent1"/>
+                </a:solidFill>
+                <a:effectLst>
+                  <a:outerShdw blurRad="38100" dist="25400" dir="5400000" algn="ctr" rotWithShape="0">
+                    <a:srgbClr val="6E747A">
+                      <a:alpha val="43000"/>
+                    </a:srgbClr>
+                  </a:outerShdw>
+                </a:effectLst>
+              </a:rPr>
+              <a:t>स्वास्थ्य</a:t>
+            </a:r>
+            <a:r>
+              <a:rPr lang="en-IN" sz="1000" dirty="0">
+                <a:ln w="0"/>
+                <a:solidFill>
+                  <a:schemeClr val="accent1"/>
+                </a:solidFill>
+                <a:effectLst>
+                  <a:outerShdw blurRad="38100" dist="25400" dir="5400000" algn="ctr" rotWithShape="0">
+                    <a:srgbClr val="6E747A">
+                      <a:alpha val="43000"/>
+                    </a:srgbClr>
+                  </a:outerShdw>
+                </a:effectLst>
+              </a:rPr>
+              <a:t> </a:t>
+            </a:r>
+            <a:r>
+              <a:rPr lang="en-IN" sz="1000" dirty="0" err="1">
+                <a:ln w="0"/>
+                <a:solidFill>
+                  <a:schemeClr val="accent1"/>
+                </a:solidFill>
+                <a:effectLst>
+                  <a:outerShdw blurRad="38100" dist="25400" dir="5400000" algn="ctr" rotWithShape="0">
+                    <a:srgbClr val="6E747A">
+                      <a:alpha val="43000"/>
+                    </a:srgbClr>
+                  </a:outerShdw>
+                </a:effectLst>
+              </a:rPr>
+              <a:t>संगठन</a:t>
+            </a:r>
+            <a:r>
+              <a:rPr lang="en-IN" sz="1000" dirty="0">
+                <a:ln w="0"/>
+                <a:solidFill>
+                  <a:schemeClr val="accent1"/>
+                </a:solidFill>
+                <a:effectLst>
+                  <a:outerShdw blurRad="38100" dist="25400" dir="5400000" algn="ctr" rotWithShape="0">
+                    <a:srgbClr val="6E747A">
+                      <a:alpha val="43000"/>
+                    </a:srgbClr>
+                  </a:outerShdw>
+                </a:effectLst>
+              </a:rPr>
+              <a:t> </a:t>
+            </a:r>
+            <a:r>
+              <a:rPr lang="en-IN" sz="1000" dirty="0" err="1">
+                <a:ln w="0"/>
+                <a:solidFill>
+                  <a:schemeClr val="accent1"/>
+                </a:solidFill>
+                <a:effectLst>
+                  <a:outerShdw blurRad="38100" dist="25400" dir="5400000" algn="ctr" rotWithShape="0">
+                    <a:srgbClr val="6E747A">
+                      <a:alpha val="43000"/>
+                    </a:srgbClr>
+                  </a:outerShdw>
+                </a:effectLst>
+              </a:rPr>
+              <a:t>ने</a:t>
+            </a:r>
+            <a:r>
+              <a:rPr lang="en-IN" sz="1000" dirty="0">
+                <a:ln w="0"/>
+                <a:solidFill>
+                  <a:schemeClr val="accent1"/>
+                </a:solidFill>
+                <a:effectLst>
+                  <a:outerShdw blurRad="38100" dist="25400" dir="5400000" algn="ctr" rotWithShape="0">
+                    <a:srgbClr val="6E747A">
+                      <a:alpha val="43000"/>
+                    </a:srgbClr>
+                  </a:outerShdw>
+                </a:effectLst>
+              </a:rPr>
+              <a:t> </a:t>
+            </a:r>
+            <a:r>
+              <a:rPr lang="en-IN" sz="1000" dirty="0" err="1">
+                <a:ln w="0"/>
+                <a:solidFill>
+                  <a:schemeClr val="accent1"/>
+                </a:solidFill>
+                <a:effectLst>
+                  <a:outerShdw blurRad="38100" dist="25400" dir="5400000" algn="ctr" rotWithShape="0">
+                    <a:srgbClr val="6E747A">
+                      <a:alpha val="43000"/>
+                    </a:srgbClr>
+                  </a:outerShdw>
+                </a:effectLst>
+              </a:rPr>
+              <a:t>बताया</a:t>
+            </a:r>
+            <a:r>
+              <a:rPr lang="en-IN" sz="1000" dirty="0">
+                <a:ln w="0"/>
+                <a:solidFill>
+                  <a:schemeClr val="accent1"/>
+                </a:solidFill>
+                <a:effectLst>
+                  <a:outerShdw blurRad="38100" dist="25400" dir="5400000" algn="ctr" rotWithShape="0">
+                    <a:srgbClr val="6E747A">
+                      <a:alpha val="43000"/>
+                    </a:srgbClr>
+                  </a:outerShdw>
+                </a:effectLst>
+              </a:rPr>
+              <a:t> </a:t>
+            </a:r>
+            <a:r>
+              <a:rPr lang="en-IN" sz="1000" dirty="0" err="1">
+                <a:ln w="0"/>
+                <a:solidFill>
+                  <a:schemeClr val="accent1"/>
+                </a:solidFill>
+                <a:effectLst>
+                  <a:outerShdw blurRad="38100" dist="25400" dir="5400000" algn="ctr" rotWithShape="0">
+                    <a:srgbClr val="6E747A">
+                      <a:alpha val="43000"/>
+                    </a:srgbClr>
+                  </a:outerShdw>
+                </a:effectLst>
+              </a:rPr>
+              <a:t>है</a:t>
+            </a:r>
+            <a:r>
+              <a:rPr lang="en-IN" sz="1000" dirty="0">
+                <a:ln w="0"/>
+                <a:solidFill>
+                  <a:schemeClr val="accent1"/>
+                </a:solidFill>
+                <a:effectLst>
+                  <a:outerShdw blurRad="38100" dist="25400" dir="5400000" algn="ctr" rotWithShape="0">
+                    <a:srgbClr val="6E747A">
+                      <a:alpha val="43000"/>
+                    </a:srgbClr>
+                  </a:outerShdw>
+                </a:effectLst>
+              </a:rPr>
+              <a:t> </a:t>
+            </a:r>
+            <a:r>
+              <a:rPr lang="en-IN" sz="1000" dirty="0" err="1">
+                <a:ln w="0"/>
+                <a:solidFill>
+                  <a:schemeClr val="accent1"/>
+                </a:solidFill>
+                <a:effectLst>
+                  <a:outerShdw blurRad="38100" dist="25400" dir="5400000" algn="ctr" rotWithShape="0">
+                    <a:srgbClr val="6E747A">
+                      <a:alpha val="43000"/>
+                    </a:srgbClr>
+                  </a:outerShdw>
+                </a:effectLst>
+              </a:rPr>
+              <a:t>कि</a:t>
+            </a:r>
+            <a:r>
+              <a:rPr lang="en-IN" sz="1000" dirty="0">
+                <a:ln w="0"/>
+                <a:solidFill>
+                  <a:schemeClr val="accent1"/>
+                </a:solidFill>
+                <a:effectLst>
+                  <a:outerShdw blurRad="38100" dist="25400" dir="5400000" algn="ctr" rotWithShape="0">
+                    <a:srgbClr val="6E747A">
+                      <a:alpha val="43000"/>
+                    </a:srgbClr>
+                  </a:outerShdw>
+                </a:effectLst>
+              </a:rPr>
+              <a:t> </a:t>
+            </a:r>
+            <a:r>
+              <a:rPr lang="en-IN" sz="1000" dirty="0" err="1">
+                <a:ln w="0"/>
+                <a:solidFill>
+                  <a:schemeClr val="accent1"/>
+                </a:solidFill>
+                <a:effectLst>
+                  <a:outerShdw blurRad="38100" dist="25400" dir="5400000" algn="ctr" rotWithShape="0">
+                    <a:srgbClr val="6E747A">
+                      <a:alpha val="43000"/>
+                    </a:srgbClr>
+                  </a:outerShdw>
+                </a:effectLst>
+              </a:rPr>
+              <a:t>बर्ड</a:t>
+            </a:r>
+            <a:r>
+              <a:rPr lang="en-IN" sz="1000" dirty="0">
+                <a:ln w="0"/>
+                <a:solidFill>
+                  <a:schemeClr val="accent1"/>
+                </a:solidFill>
+                <a:effectLst>
+                  <a:outerShdw blurRad="38100" dist="25400" dir="5400000" algn="ctr" rotWithShape="0">
+                    <a:srgbClr val="6E747A">
+                      <a:alpha val="43000"/>
+                    </a:srgbClr>
+                  </a:outerShdw>
+                </a:effectLst>
+              </a:rPr>
+              <a:t> </a:t>
+            </a:r>
+            <a:r>
+              <a:rPr lang="en-IN" sz="1000" dirty="0" err="1">
+                <a:ln w="0"/>
+                <a:solidFill>
+                  <a:schemeClr val="accent1"/>
+                </a:solidFill>
+                <a:effectLst>
+                  <a:outerShdw blurRad="38100" dist="25400" dir="5400000" algn="ctr" rotWithShape="0">
+                    <a:srgbClr val="6E747A">
+                      <a:alpha val="43000"/>
+                    </a:srgbClr>
+                  </a:outerShdw>
+                </a:effectLst>
+              </a:rPr>
+              <a:t>फ़्लू</a:t>
+            </a:r>
+            <a:r>
+              <a:rPr lang="en-IN" sz="1000" dirty="0">
+                <a:ln w="0"/>
+                <a:solidFill>
+                  <a:schemeClr val="accent1"/>
+                </a:solidFill>
+                <a:effectLst>
+                  <a:outerShdw blurRad="38100" dist="25400" dir="5400000" algn="ctr" rotWithShape="0">
+                    <a:srgbClr val="6E747A">
+                      <a:alpha val="43000"/>
+                    </a:srgbClr>
+                  </a:outerShdw>
+                </a:effectLst>
+              </a:rPr>
+              <a:t> </a:t>
+            </a:r>
+            <a:r>
+              <a:rPr lang="en-IN" sz="1000" dirty="0" err="1">
+                <a:ln w="0"/>
+                <a:solidFill>
+                  <a:schemeClr val="accent1"/>
+                </a:solidFill>
+                <a:effectLst>
+                  <a:outerShdw blurRad="38100" dist="25400" dir="5400000" algn="ctr" rotWithShape="0">
+                    <a:srgbClr val="6E747A">
+                      <a:alpha val="43000"/>
+                    </a:srgbClr>
+                  </a:outerShdw>
+                </a:effectLst>
+              </a:rPr>
+              <a:t>के</a:t>
+            </a:r>
+            <a:r>
+              <a:rPr lang="en-IN" sz="1000" dirty="0">
+                <a:ln w="0"/>
+                <a:solidFill>
+                  <a:schemeClr val="accent1"/>
+                </a:solidFill>
+                <a:effectLst>
+                  <a:outerShdw blurRad="38100" dist="25400" dir="5400000" algn="ctr" rotWithShape="0">
+                    <a:srgbClr val="6E747A">
+                      <a:alpha val="43000"/>
+                    </a:srgbClr>
+                  </a:outerShdw>
+                </a:effectLst>
+              </a:rPr>
+              <a:t> एच5एन1 </a:t>
+            </a:r>
+            <a:r>
+              <a:rPr lang="en-IN" sz="1000" dirty="0" err="1">
+                <a:ln w="0"/>
+                <a:solidFill>
+                  <a:schemeClr val="accent1"/>
+                </a:solidFill>
+                <a:effectLst>
+                  <a:outerShdw blurRad="38100" dist="25400" dir="5400000" algn="ctr" rotWithShape="0">
+                    <a:srgbClr val="6E747A">
+                      <a:alpha val="43000"/>
+                    </a:srgbClr>
+                  </a:outerShdw>
+                </a:effectLst>
+              </a:rPr>
+              <a:t>वायरस</a:t>
+            </a:r>
+            <a:r>
+              <a:rPr lang="en-IN" sz="1000" dirty="0">
+                <a:ln w="0"/>
+                <a:solidFill>
+                  <a:schemeClr val="accent1"/>
+                </a:solidFill>
+                <a:effectLst>
+                  <a:outerShdw blurRad="38100" dist="25400" dir="5400000" algn="ctr" rotWithShape="0">
+                    <a:srgbClr val="6E747A">
+                      <a:alpha val="43000"/>
+                    </a:srgbClr>
+                  </a:outerShdw>
+                </a:effectLst>
+              </a:rPr>
+              <a:t> </a:t>
+            </a:r>
+            <a:r>
+              <a:rPr lang="en-IN" sz="1000" dirty="0" err="1">
+                <a:ln w="0"/>
+                <a:solidFill>
+                  <a:schemeClr val="accent1"/>
+                </a:solidFill>
+                <a:effectLst>
+                  <a:outerShdw blurRad="38100" dist="25400" dir="5400000" algn="ctr" rotWithShape="0">
+                    <a:srgbClr val="6E747A">
+                      <a:alpha val="43000"/>
+                    </a:srgbClr>
+                  </a:outerShdw>
+                </a:effectLst>
+              </a:rPr>
+              <a:t>से</a:t>
+            </a:r>
+            <a:r>
+              <a:rPr lang="en-IN" sz="1000" dirty="0">
+                <a:ln w="0"/>
+                <a:solidFill>
+                  <a:schemeClr val="accent1"/>
+                </a:solidFill>
+                <a:effectLst>
+                  <a:outerShdw blurRad="38100" dist="25400" dir="5400000" algn="ctr" rotWithShape="0">
+                    <a:srgbClr val="6E747A">
+                      <a:alpha val="43000"/>
+                    </a:srgbClr>
+                  </a:outerShdw>
+                </a:effectLst>
+              </a:rPr>
+              <a:t> </a:t>
+            </a:r>
+            <a:r>
+              <a:rPr lang="en-IN" sz="1000" dirty="0" err="1">
+                <a:ln w="0"/>
+                <a:solidFill>
+                  <a:schemeClr val="accent1"/>
+                </a:solidFill>
+                <a:effectLst>
+                  <a:outerShdw blurRad="38100" dist="25400" dir="5400000" algn="ctr" rotWithShape="0">
+                    <a:srgbClr val="6E747A">
+                      <a:alpha val="43000"/>
+                    </a:srgbClr>
+                  </a:outerShdw>
+                </a:effectLst>
+              </a:rPr>
+              <a:t>मौत</a:t>
+            </a:r>
+            <a:r>
+              <a:rPr lang="en-IN" sz="1000" dirty="0">
+                <a:ln w="0"/>
+                <a:solidFill>
+                  <a:schemeClr val="accent1"/>
+                </a:solidFill>
+                <a:effectLst>
+                  <a:outerShdw blurRad="38100" dist="25400" dir="5400000" algn="ctr" rotWithShape="0">
+                    <a:srgbClr val="6E747A">
+                      <a:alpha val="43000"/>
+                    </a:srgbClr>
+                  </a:outerShdw>
+                </a:effectLst>
+              </a:rPr>
+              <a:t> </a:t>
+            </a:r>
+            <a:r>
+              <a:rPr lang="en-IN" sz="1000" dirty="0" err="1">
+                <a:ln w="0"/>
+                <a:solidFill>
+                  <a:schemeClr val="accent1"/>
+                </a:solidFill>
+                <a:effectLst>
+                  <a:outerShdw blurRad="38100" dist="25400" dir="5400000" algn="ctr" rotWithShape="0">
+                    <a:srgbClr val="6E747A">
+                      <a:alpha val="43000"/>
+                    </a:srgbClr>
+                  </a:outerShdw>
+                </a:effectLst>
+              </a:rPr>
+              <a:t>के</a:t>
+            </a:r>
+            <a:r>
+              <a:rPr lang="en-IN" sz="1000" dirty="0">
+                <a:ln w="0"/>
+                <a:solidFill>
+                  <a:schemeClr val="accent1"/>
+                </a:solidFill>
+                <a:effectLst>
+                  <a:outerShdw blurRad="38100" dist="25400" dir="5400000" algn="ctr" rotWithShape="0">
+                    <a:srgbClr val="6E747A">
+                      <a:alpha val="43000"/>
+                    </a:srgbClr>
+                  </a:outerShdw>
+                </a:effectLst>
+              </a:rPr>
+              <a:t> </a:t>
+            </a:r>
+            <a:r>
+              <a:rPr lang="en-IN" sz="1000" dirty="0" err="1">
+                <a:ln w="0"/>
+                <a:solidFill>
+                  <a:schemeClr val="accent1"/>
+                </a:solidFill>
+                <a:effectLst>
+                  <a:outerShdw blurRad="38100" dist="25400" dir="5400000" algn="ctr" rotWithShape="0">
+                    <a:srgbClr val="6E747A">
+                      <a:alpha val="43000"/>
+                    </a:srgbClr>
+                  </a:outerShdw>
+                </a:effectLst>
+              </a:rPr>
+              <a:t>ताज़ा</a:t>
+            </a:r>
+            <a:r>
+              <a:rPr lang="en-IN" sz="1000" dirty="0">
+                <a:ln w="0"/>
+                <a:solidFill>
+                  <a:schemeClr val="accent1"/>
+                </a:solidFill>
+                <a:effectLst>
+                  <a:outerShdw blurRad="38100" dist="25400" dir="5400000" algn="ctr" rotWithShape="0">
+                    <a:srgbClr val="6E747A">
+                      <a:alpha val="43000"/>
+                    </a:srgbClr>
+                  </a:outerShdw>
+                </a:effectLst>
+              </a:rPr>
+              <a:t> </a:t>
+            </a:r>
+            <a:r>
+              <a:rPr lang="en-IN" sz="1000" dirty="0" err="1">
+                <a:ln w="0"/>
+                <a:solidFill>
+                  <a:schemeClr val="accent1"/>
+                </a:solidFill>
+                <a:effectLst>
+                  <a:outerShdw blurRad="38100" dist="25400" dir="5400000" algn="ctr" rotWithShape="0">
+                    <a:srgbClr val="6E747A">
+                      <a:alpha val="43000"/>
+                    </a:srgbClr>
+                  </a:outerShdw>
+                </a:effectLst>
+              </a:rPr>
+              <a:t>मामले</a:t>
+            </a:r>
+            <a:r>
+              <a:rPr lang="en-IN" sz="1000" dirty="0">
+                <a:ln w="0"/>
+                <a:solidFill>
+                  <a:schemeClr val="accent1"/>
+                </a:solidFill>
+                <a:effectLst>
+                  <a:outerShdw blurRad="38100" dist="25400" dir="5400000" algn="ctr" rotWithShape="0">
+                    <a:srgbClr val="6E747A">
+                      <a:alpha val="43000"/>
+                    </a:srgbClr>
+                  </a:outerShdw>
+                </a:effectLst>
+              </a:rPr>
+              <a:t> </a:t>
+            </a:r>
+            <a:r>
+              <a:rPr lang="en-IN" sz="1000" dirty="0" err="1">
+                <a:ln w="0"/>
+                <a:solidFill>
+                  <a:schemeClr val="accent1"/>
+                </a:solidFill>
+                <a:effectLst>
+                  <a:outerShdw blurRad="38100" dist="25400" dir="5400000" algn="ctr" rotWithShape="0">
+                    <a:srgbClr val="6E747A">
+                      <a:alpha val="43000"/>
+                    </a:srgbClr>
+                  </a:outerShdw>
+                </a:effectLst>
+              </a:rPr>
+              <a:t>अज़रबैजान</a:t>
+            </a:r>
+            <a:r>
+              <a:rPr lang="en-IN" sz="1000" dirty="0">
+                <a:ln w="0"/>
+                <a:solidFill>
+                  <a:schemeClr val="accent1"/>
+                </a:solidFill>
+                <a:effectLst>
+                  <a:outerShdw blurRad="38100" dist="25400" dir="5400000" algn="ctr" rotWithShape="0">
+                    <a:srgbClr val="6E747A">
+                      <a:alpha val="43000"/>
+                    </a:srgbClr>
+                  </a:outerShdw>
+                </a:effectLst>
+              </a:rPr>
+              <a:t> </a:t>
+            </a:r>
+            <a:r>
+              <a:rPr lang="en-IN" sz="1000" dirty="0" err="1">
+                <a:ln w="0"/>
+                <a:solidFill>
+                  <a:schemeClr val="accent1"/>
+                </a:solidFill>
+                <a:effectLst>
+                  <a:outerShdw blurRad="38100" dist="25400" dir="5400000" algn="ctr" rotWithShape="0">
+                    <a:srgbClr val="6E747A">
+                      <a:alpha val="43000"/>
+                    </a:srgbClr>
+                  </a:outerShdw>
+                </a:effectLst>
+              </a:rPr>
+              <a:t>में</a:t>
+            </a:r>
+            <a:r>
+              <a:rPr lang="en-IN" sz="1000" dirty="0">
+                <a:ln w="0"/>
+                <a:solidFill>
+                  <a:schemeClr val="accent1"/>
+                </a:solidFill>
+                <a:effectLst>
+                  <a:outerShdw blurRad="38100" dist="25400" dir="5400000" algn="ctr" rotWithShape="0">
+                    <a:srgbClr val="6E747A">
+                      <a:alpha val="43000"/>
+                    </a:srgbClr>
+                  </a:outerShdw>
+                </a:effectLst>
+              </a:rPr>
+              <a:t> </a:t>
+            </a:r>
+            <a:r>
+              <a:rPr lang="en-IN" sz="1000" dirty="0" err="1">
+                <a:ln w="0"/>
+                <a:solidFill>
+                  <a:schemeClr val="accent1"/>
+                </a:solidFill>
+                <a:effectLst>
+                  <a:outerShdw blurRad="38100" dist="25400" dir="5400000" algn="ctr" rotWithShape="0">
+                    <a:srgbClr val="6E747A">
+                      <a:alpha val="43000"/>
+                    </a:srgbClr>
+                  </a:outerShdw>
+                </a:effectLst>
+              </a:rPr>
+              <a:t>सामने</a:t>
+            </a:r>
+            <a:r>
+              <a:rPr lang="en-IN" sz="1000" dirty="0">
+                <a:ln w="0"/>
+                <a:solidFill>
+                  <a:schemeClr val="accent1"/>
+                </a:solidFill>
+                <a:effectLst>
+                  <a:outerShdw blurRad="38100" dist="25400" dir="5400000" algn="ctr" rotWithShape="0">
+                    <a:srgbClr val="6E747A">
+                      <a:alpha val="43000"/>
+                    </a:srgbClr>
+                  </a:outerShdw>
+                </a:effectLst>
+              </a:rPr>
+              <a:t> </a:t>
+            </a:r>
+            <a:r>
+              <a:rPr lang="en-IN" sz="1000" dirty="0" err="1">
+                <a:ln w="0"/>
+                <a:solidFill>
+                  <a:schemeClr val="accent1"/>
+                </a:solidFill>
+                <a:effectLst>
+                  <a:outerShdw blurRad="38100" dist="25400" dir="5400000" algn="ctr" rotWithShape="0">
+                    <a:srgbClr val="6E747A">
+                      <a:alpha val="43000"/>
+                    </a:srgbClr>
+                  </a:outerShdw>
+                </a:effectLst>
+              </a:rPr>
+              <a:t>आए</a:t>
+            </a:r>
+            <a:r>
+              <a:rPr lang="en-IN" sz="1000" dirty="0">
+                <a:ln w="0"/>
+                <a:solidFill>
+                  <a:schemeClr val="accent1"/>
+                </a:solidFill>
+                <a:effectLst>
+                  <a:outerShdw blurRad="38100" dist="25400" dir="5400000" algn="ctr" rotWithShape="0">
+                    <a:srgbClr val="6E747A">
+                      <a:alpha val="43000"/>
+                    </a:srgbClr>
+                  </a:outerShdw>
+                </a:effectLst>
+              </a:rPr>
+              <a:t> </a:t>
+            </a:r>
+            <a:r>
+              <a:rPr lang="en-IN" sz="1000" dirty="0" err="1">
+                <a:ln w="0"/>
+                <a:solidFill>
+                  <a:schemeClr val="accent1"/>
+                </a:solidFill>
+                <a:effectLst>
+                  <a:outerShdw blurRad="38100" dist="25400" dir="5400000" algn="ctr" rotWithShape="0">
+                    <a:srgbClr val="6E747A">
+                      <a:alpha val="43000"/>
+                    </a:srgbClr>
+                  </a:outerShdw>
+                </a:effectLst>
+              </a:rPr>
+              <a:t>हैं</a:t>
+            </a:r>
+            <a:r>
+              <a:rPr lang="en-IN" sz="1000" dirty="0">
+                <a:ln w="0"/>
+                <a:solidFill>
+                  <a:schemeClr val="accent1"/>
+                </a:solidFill>
+                <a:effectLst>
+                  <a:outerShdw blurRad="38100" dist="25400" dir="5400000" algn="ctr" rotWithShape="0">
+                    <a:srgbClr val="6E747A">
+                      <a:alpha val="43000"/>
+                    </a:srgbClr>
+                  </a:outerShdw>
+                </a:effectLst>
+              </a:rPr>
+              <a:t>। </a:t>
+            </a:r>
+            <a:r>
+              <a:rPr lang="en-IN" sz="1000" dirty="0" err="1">
+                <a:ln w="0"/>
+                <a:solidFill>
+                  <a:schemeClr val="accent1"/>
+                </a:solidFill>
+                <a:effectLst>
+                  <a:outerShdw blurRad="38100" dist="25400" dir="5400000" algn="ctr" rotWithShape="0">
+                    <a:srgbClr val="6E747A">
+                      <a:alpha val="43000"/>
+                    </a:srgbClr>
+                  </a:outerShdw>
+                </a:effectLst>
+              </a:rPr>
+              <a:t>अज़रबैजान</a:t>
+            </a:r>
+            <a:r>
+              <a:rPr lang="en-IN" sz="1000" dirty="0">
+                <a:ln w="0"/>
+                <a:solidFill>
+                  <a:schemeClr val="accent1"/>
+                </a:solidFill>
+                <a:effectLst>
+                  <a:outerShdw blurRad="38100" dist="25400" dir="5400000" algn="ctr" rotWithShape="0">
+                    <a:srgbClr val="6E747A">
+                      <a:alpha val="43000"/>
+                    </a:srgbClr>
+                  </a:outerShdw>
+                </a:effectLst>
+              </a:rPr>
+              <a:t> </a:t>
+            </a:r>
+            <a:r>
+              <a:rPr lang="en-IN" sz="1000" dirty="0" err="1">
+                <a:ln w="0"/>
+                <a:solidFill>
+                  <a:schemeClr val="accent1"/>
+                </a:solidFill>
+                <a:effectLst>
+                  <a:outerShdw blurRad="38100" dist="25400" dir="5400000" algn="ctr" rotWithShape="0">
+                    <a:srgbClr val="6E747A">
+                      <a:alpha val="43000"/>
+                    </a:srgbClr>
+                  </a:outerShdw>
+                </a:effectLst>
+              </a:rPr>
+              <a:t>में</a:t>
+            </a:r>
+            <a:r>
+              <a:rPr lang="en-IN" sz="1000" dirty="0">
+                <a:ln w="0"/>
+                <a:solidFill>
+                  <a:schemeClr val="accent1"/>
+                </a:solidFill>
+                <a:effectLst>
+                  <a:outerShdw blurRad="38100" dist="25400" dir="5400000" algn="ctr" rotWithShape="0">
+                    <a:srgbClr val="6E747A">
+                      <a:alpha val="43000"/>
+                    </a:srgbClr>
+                  </a:outerShdw>
+                </a:effectLst>
+              </a:rPr>
+              <a:t> </a:t>
+            </a:r>
+            <a:r>
+              <a:rPr lang="en-IN" sz="1000" dirty="0" err="1">
+                <a:ln w="0"/>
+                <a:solidFill>
+                  <a:schemeClr val="accent1"/>
+                </a:solidFill>
+                <a:effectLst>
+                  <a:outerShdw blurRad="38100" dist="25400" dir="5400000" algn="ctr" rotWithShape="0">
+                    <a:srgbClr val="6E747A">
+                      <a:alpha val="43000"/>
+                    </a:srgbClr>
+                  </a:outerShdw>
+                </a:effectLst>
+              </a:rPr>
+              <a:t>फ़रवरी</a:t>
+            </a:r>
+            <a:r>
+              <a:rPr lang="en-IN" sz="1000" dirty="0">
+                <a:ln w="0"/>
+                <a:solidFill>
+                  <a:schemeClr val="accent1"/>
+                </a:solidFill>
+                <a:effectLst>
+                  <a:outerShdw blurRad="38100" dist="25400" dir="5400000" algn="ctr" rotWithShape="0">
+                    <a:srgbClr val="6E747A">
+                      <a:alpha val="43000"/>
+                    </a:srgbClr>
+                  </a:outerShdw>
+                </a:effectLst>
+              </a:rPr>
+              <a:t> </a:t>
+            </a:r>
+            <a:r>
+              <a:rPr lang="en-IN" sz="1000" dirty="0" err="1">
+                <a:ln w="0"/>
+                <a:solidFill>
+                  <a:schemeClr val="accent1"/>
+                </a:solidFill>
+                <a:effectLst>
+                  <a:outerShdw blurRad="38100" dist="25400" dir="5400000" algn="ctr" rotWithShape="0">
+                    <a:srgbClr val="6E747A">
+                      <a:alpha val="43000"/>
+                    </a:srgbClr>
+                  </a:outerShdw>
+                </a:effectLst>
+              </a:rPr>
+              <a:t>के</a:t>
+            </a:r>
+            <a:r>
+              <a:rPr lang="en-IN" sz="1000" dirty="0">
+                <a:ln w="0"/>
+                <a:solidFill>
+                  <a:schemeClr val="accent1"/>
+                </a:solidFill>
+                <a:effectLst>
+                  <a:outerShdw blurRad="38100" dist="25400" dir="5400000" algn="ctr" rotWithShape="0">
+                    <a:srgbClr val="6E747A">
+                      <a:alpha val="43000"/>
+                    </a:srgbClr>
+                  </a:outerShdw>
+                </a:effectLst>
+              </a:rPr>
+              <a:t> </a:t>
+            </a:r>
+            <a:r>
+              <a:rPr lang="en-IN" sz="1000" dirty="0" err="1">
+                <a:ln w="0"/>
+                <a:solidFill>
+                  <a:schemeClr val="accent1"/>
+                </a:solidFill>
+                <a:effectLst>
+                  <a:outerShdw blurRad="38100" dist="25400" dir="5400000" algn="ctr" rotWithShape="0">
+                    <a:srgbClr val="6E747A">
+                      <a:alpha val="43000"/>
+                    </a:srgbClr>
+                  </a:outerShdw>
+                </a:effectLst>
+              </a:rPr>
+              <a:t>बाद</a:t>
+            </a:r>
+            <a:r>
+              <a:rPr lang="en-IN" sz="1000" dirty="0">
+                <a:ln w="0"/>
+                <a:solidFill>
+                  <a:schemeClr val="accent1"/>
+                </a:solidFill>
+                <a:effectLst>
+                  <a:outerShdw blurRad="38100" dist="25400" dir="5400000" algn="ctr" rotWithShape="0">
+                    <a:srgbClr val="6E747A">
+                      <a:alpha val="43000"/>
+                    </a:srgbClr>
+                  </a:outerShdw>
+                </a:effectLst>
+              </a:rPr>
+              <a:t> </a:t>
+            </a:r>
+            <a:r>
+              <a:rPr lang="en-IN" sz="1000" dirty="0" err="1">
+                <a:ln w="0"/>
+                <a:solidFill>
+                  <a:schemeClr val="accent1"/>
+                </a:solidFill>
+                <a:effectLst>
+                  <a:outerShdw blurRad="38100" dist="25400" dir="5400000" algn="ctr" rotWithShape="0">
+                    <a:srgbClr val="6E747A">
+                      <a:alpha val="43000"/>
+                    </a:srgbClr>
+                  </a:outerShdw>
+                </a:effectLst>
+              </a:rPr>
+              <a:t>से</a:t>
+            </a:r>
+            <a:r>
+              <a:rPr lang="en-IN" sz="1000" dirty="0">
+                <a:ln w="0"/>
+                <a:solidFill>
+                  <a:schemeClr val="accent1"/>
+                </a:solidFill>
+                <a:effectLst>
+                  <a:outerShdw blurRad="38100" dist="25400" dir="5400000" algn="ctr" rotWithShape="0">
+                    <a:srgbClr val="6E747A">
+                      <a:alpha val="43000"/>
+                    </a:srgbClr>
+                  </a:outerShdw>
+                </a:effectLst>
+              </a:rPr>
+              <a:t> </a:t>
+            </a:r>
+            <a:r>
+              <a:rPr lang="en-IN" sz="1000" dirty="0" err="1">
+                <a:ln w="0"/>
+                <a:solidFill>
+                  <a:schemeClr val="accent1"/>
+                </a:solidFill>
+                <a:effectLst>
+                  <a:outerShdw blurRad="38100" dist="25400" dir="5400000" algn="ctr" rotWithShape="0">
+                    <a:srgbClr val="6E747A">
+                      <a:alpha val="43000"/>
+                    </a:srgbClr>
+                  </a:outerShdw>
+                </a:effectLst>
+              </a:rPr>
+              <a:t>बर्ड</a:t>
+            </a:r>
+            <a:r>
+              <a:rPr lang="en-IN" sz="1000" dirty="0">
+                <a:ln w="0"/>
+                <a:solidFill>
+                  <a:schemeClr val="accent1"/>
+                </a:solidFill>
+                <a:effectLst>
+                  <a:outerShdw blurRad="38100" dist="25400" dir="5400000" algn="ctr" rotWithShape="0">
+                    <a:srgbClr val="6E747A">
+                      <a:alpha val="43000"/>
+                    </a:srgbClr>
+                  </a:outerShdw>
+                </a:effectLst>
+              </a:rPr>
+              <a:t> </a:t>
+            </a:r>
+            <a:r>
+              <a:rPr lang="en-IN" sz="1000" dirty="0" err="1">
+                <a:ln w="0"/>
+                <a:solidFill>
+                  <a:schemeClr val="accent1"/>
+                </a:solidFill>
+                <a:effectLst>
+                  <a:outerShdw blurRad="38100" dist="25400" dir="5400000" algn="ctr" rotWithShape="0">
+                    <a:srgbClr val="6E747A">
+                      <a:alpha val="43000"/>
+                    </a:srgbClr>
+                  </a:outerShdw>
+                </a:effectLst>
+              </a:rPr>
+              <a:t>फ़्लू</a:t>
+            </a:r>
+            <a:r>
+              <a:rPr lang="en-IN" sz="1000" dirty="0">
+                <a:ln w="0"/>
+                <a:solidFill>
+                  <a:schemeClr val="accent1"/>
+                </a:solidFill>
+                <a:effectLst>
+                  <a:outerShdw blurRad="38100" dist="25400" dir="5400000" algn="ctr" rotWithShape="0">
+                    <a:srgbClr val="6E747A">
+                      <a:alpha val="43000"/>
+                    </a:srgbClr>
+                  </a:outerShdw>
+                </a:effectLst>
+              </a:rPr>
+              <a:t> </a:t>
+            </a:r>
+            <a:r>
+              <a:rPr lang="en-IN" sz="1000" dirty="0" err="1">
+                <a:ln w="0"/>
+                <a:solidFill>
+                  <a:schemeClr val="accent1"/>
+                </a:solidFill>
+                <a:effectLst>
+                  <a:outerShdw blurRad="38100" dist="25400" dir="5400000" algn="ctr" rotWithShape="0">
+                    <a:srgbClr val="6E747A">
+                      <a:alpha val="43000"/>
+                    </a:srgbClr>
+                  </a:outerShdw>
+                </a:effectLst>
+              </a:rPr>
+              <a:t>के</a:t>
+            </a:r>
+            <a:r>
+              <a:rPr lang="en-IN" sz="1000" dirty="0">
+                <a:ln w="0"/>
+                <a:solidFill>
+                  <a:schemeClr val="accent1"/>
+                </a:solidFill>
+                <a:effectLst>
+                  <a:outerShdw blurRad="38100" dist="25400" dir="5400000" algn="ctr" rotWithShape="0">
+                    <a:srgbClr val="6E747A">
+                      <a:alpha val="43000"/>
+                    </a:srgbClr>
+                  </a:outerShdw>
+                </a:effectLst>
+              </a:rPr>
+              <a:t> </a:t>
+            </a:r>
+            <a:r>
+              <a:rPr lang="en-IN" sz="1000" dirty="0" err="1">
+                <a:ln w="0"/>
+                <a:solidFill>
+                  <a:schemeClr val="accent1"/>
+                </a:solidFill>
+                <a:effectLst>
+                  <a:outerShdw blurRad="38100" dist="25400" dir="5400000" algn="ctr" rotWithShape="0">
+                    <a:srgbClr val="6E747A">
+                      <a:alpha val="43000"/>
+                    </a:srgbClr>
+                  </a:outerShdw>
+                </a:effectLst>
+              </a:rPr>
+              <a:t>लक्षण</a:t>
+            </a:r>
+            <a:r>
+              <a:rPr lang="en-IN" sz="1000" dirty="0">
+                <a:ln w="0"/>
+                <a:solidFill>
+                  <a:schemeClr val="accent1"/>
+                </a:solidFill>
+                <a:effectLst>
+                  <a:outerShdw blurRad="38100" dist="25400" dir="5400000" algn="ctr" rotWithShape="0">
+                    <a:srgbClr val="6E747A">
+                      <a:alpha val="43000"/>
+                    </a:srgbClr>
+                  </a:outerShdw>
+                </a:effectLst>
+              </a:rPr>
+              <a:t> </a:t>
+            </a:r>
+            <a:r>
+              <a:rPr lang="en-IN" sz="1000" dirty="0" err="1">
+                <a:ln w="0"/>
+                <a:solidFill>
+                  <a:schemeClr val="accent1"/>
+                </a:solidFill>
+                <a:effectLst>
+                  <a:outerShdw blurRad="38100" dist="25400" dir="5400000" algn="ctr" rotWithShape="0">
+                    <a:srgbClr val="6E747A">
+                      <a:alpha val="43000"/>
+                    </a:srgbClr>
+                  </a:outerShdw>
+                </a:effectLst>
+              </a:rPr>
+              <a:t>वाले</a:t>
+            </a:r>
+            <a:r>
+              <a:rPr lang="en-IN" sz="1000" dirty="0">
+                <a:ln w="0"/>
+                <a:solidFill>
+                  <a:schemeClr val="accent1"/>
+                </a:solidFill>
+                <a:effectLst>
+                  <a:outerShdw blurRad="38100" dist="25400" dir="5400000" algn="ctr" rotWithShape="0">
+                    <a:srgbClr val="6E747A">
+                      <a:alpha val="43000"/>
+                    </a:srgbClr>
+                  </a:outerShdw>
+                </a:effectLst>
+              </a:rPr>
+              <a:t> 11 </a:t>
+            </a:r>
+            <a:r>
+              <a:rPr lang="en-IN" sz="1000" dirty="0" err="1">
+                <a:ln w="0"/>
+                <a:solidFill>
+                  <a:schemeClr val="accent1"/>
+                </a:solidFill>
+                <a:effectLst>
+                  <a:outerShdw blurRad="38100" dist="25400" dir="5400000" algn="ctr" rotWithShape="0">
+                    <a:srgbClr val="6E747A">
+                      <a:alpha val="43000"/>
+                    </a:srgbClr>
+                  </a:outerShdw>
+                </a:effectLst>
+              </a:rPr>
+              <a:t>मामलों</a:t>
+            </a:r>
+            <a:r>
+              <a:rPr lang="en-IN" sz="1000" dirty="0">
+                <a:ln w="0"/>
+                <a:solidFill>
+                  <a:schemeClr val="accent1"/>
+                </a:solidFill>
+                <a:effectLst>
+                  <a:outerShdw blurRad="38100" dist="25400" dir="5400000" algn="ctr" rotWithShape="0">
+                    <a:srgbClr val="6E747A">
+                      <a:alpha val="43000"/>
+                    </a:srgbClr>
+                  </a:outerShdw>
+                </a:effectLst>
+              </a:rPr>
+              <a:t> </a:t>
+            </a:r>
+            <a:r>
+              <a:rPr lang="en-IN" sz="1000" dirty="0" err="1">
+                <a:ln w="0"/>
+                <a:solidFill>
+                  <a:schemeClr val="accent1"/>
+                </a:solidFill>
+                <a:effectLst>
+                  <a:outerShdw blurRad="38100" dist="25400" dir="5400000" algn="ctr" rotWithShape="0">
+                    <a:srgbClr val="6E747A">
+                      <a:alpha val="43000"/>
+                    </a:srgbClr>
+                  </a:outerShdw>
+                </a:effectLst>
+              </a:rPr>
+              <a:t>में</a:t>
+            </a:r>
+            <a:r>
+              <a:rPr lang="en-IN" sz="1000" dirty="0">
+                <a:ln w="0"/>
+                <a:solidFill>
+                  <a:schemeClr val="accent1"/>
+                </a:solidFill>
+                <a:effectLst>
+                  <a:outerShdw blurRad="38100" dist="25400" dir="5400000" algn="ctr" rotWithShape="0">
+                    <a:srgbClr val="6E747A">
+                      <a:alpha val="43000"/>
+                    </a:srgbClr>
+                  </a:outerShdw>
+                </a:effectLst>
+              </a:rPr>
+              <a:t> </a:t>
+            </a:r>
+            <a:r>
+              <a:rPr lang="en-IN" sz="1000" dirty="0" err="1">
+                <a:ln w="0"/>
+                <a:solidFill>
+                  <a:schemeClr val="accent1"/>
+                </a:solidFill>
+                <a:effectLst>
+                  <a:outerShdw blurRad="38100" dist="25400" dir="5400000" algn="ctr" rotWithShape="0">
+                    <a:srgbClr val="6E747A">
+                      <a:alpha val="43000"/>
+                    </a:srgbClr>
+                  </a:outerShdw>
+                </a:effectLst>
+              </a:rPr>
+              <a:t>से</a:t>
+            </a:r>
+            <a:r>
+              <a:rPr lang="en-IN" sz="1000" dirty="0">
+                <a:ln w="0"/>
+                <a:solidFill>
+                  <a:schemeClr val="accent1"/>
+                </a:solidFill>
+                <a:effectLst>
+                  <a:outerShdw blurRad="38100" dist="25400" dir="5400000" algn="ctr" rotWithShape="0">
+                    <a:srgbClr val="6E747A">
+                      <a:alpha val="43000"/>
+                    </a:srgbClr>
+                  </a:outerShdw>
+                </a:effectLst>
+              </a:rPr>
+              <a:t> 5 </a:t>
+            </a:r>
+            <a:r>
+              <a:rPr lang="en-IN" sz="1000" dirty="0" err="1">
+                <a:ln w="0"/>
+                <a:solidFill>
+                  <a:schemeClr val="accent1"/>
+                </a:solidFill>
+                <a:effectLst>
+                  <a:outerShdw blurRad="38100" dist="25400" dir="5400000" algn="ctr" rotWithShape="0">
+                    <a:srgbClr val="6E747A">
+                      <a:alpha val="43000"/>
+                    </a:srgbClr>
+                  </a:outerShdw>
+                </a:effectLst>
+              </a:rPr>
+              <a:t>लोगों</a:t>
+            </a:r>
+            <a:r>
+              <a:rPr lang="en-IN" sz="1000" dirty="0">
+                <a:ln w="0"/>
+                <a:solidFill>
+                  <a:schemeClr val="accent1"/>
+                </a:solidFill>
+                <a:effectLst>
+                  <a:outerShdw blurRad="38100" dist="25400" dir="5400000" algn="ctr" rotWithShape="0">
+                    <a:srgbClr val="6E747A">
+                      <a:alpha val="43000"/>
+                    </a:srgbClr>
+                  </a:outerShdw>
+                </a:effectLst>
+              </a:rPr>
+              <a:t> </a:t>
+            </a:r>
+            <a:r>
+              <a:rPr lang="en-IN" sz="1000" dirty="0" err="1">
+                <a:ln w="0"/>
+                <a:solidFill>
+                  <a:schemeClr val="accent1"/>
+                </a:solidFill>
+                <a:effectLst>
+                  <a:outerShdw blurRad="38100" dist="25400" dir="5400000" algn="ctr" rotWithShape="0">
+                    <a:srgbClr val="6E747A">
+                      <a:alpha val="43000"/>
+                    </a:srgbClr>
+                  </a:outerShdw>
+                </a:effectLst>
+              </a:rPr>
+              <a:t>की</a:t>
+            </a:r>
+            <a:r>
+              <a:rPr lang="en-IN" sz="1000" dirty="0">
+                <a:ln w="0"/>
+                <a:solidFill>
+                  <a:schemeClr val="accent1"/>
+                </a:solidFill>
+                <a:effectLst>
+                  <a:outerShdw blurRad="38100" dist="25400" dir="5400000" algn="ctr" rotWithShape="0">
+                    <a:srgbClr val="6E747A">
+                      <a:alpha val="43000"/>
+                    </a:srgbClr>
+                  </a:outerShdw>
+                </a:effectLst>
+              </a:rPr>
+              <a:t> </a:t>
+            </a:r>
+            <a:r>
+              <a:rPr lang="en-IN" sz="1000" dirty="0" err="1">
+                <a:ln w="0"/>
+                <a:solidFill>
+                  <a:schemeClr val="accent1"/>
+                </a:solidFill>
+                <a:effectLst>
+                  <a:outerShdw blurRad="38100" dist="25400" dir="5400000" algn="ctr" rotWithShape="0">
+                    <a:srgbClr val="6E747A">
+                      <a:alpha val="43000"/>
+                    </a:srgbClr>
+                  </a:outerShdw>
+                </a:effectLst>
+              </a:rPr>
+              <a:t>मौत</a:t>
+            </a:r>
+            <a:r>
+              <a:rPr lang="en-IN" sz="1000" dirty="0">
+                <a:ln w="0"/>
+                <a:solidFill>
+                  <a:schemeClr val="accent1"/>
+                </a:solidFill>
+                <a:effectLst>
+                  <a:outerShdw blurRad="38100" dist="25400" dir="5400000" algn="ctr" rotWithShape="0">
+                    <a:srgbClr val="6E747A">
+                      <a:alpha val="43000"/>
+                    </a:srgbClr>
+                  </a:outerShdw>
+                </a:effectLst>
+              </a:rPr>
+              <a:t> </a:t>
+            </a:r>
+            <a:r>
+              <a:rPr lang="en-IN" sz="1000" dirty="0" err="1">
+                <a:ln w="0"/>
+                <a:solidFill>
+                  <a:schemeClr val="accent1"/>
+                </a:solidFill>
+                <a:effectLst>
+                  <a:outerShdw blurRad="38100" dist="25400" dir="5400000" algn="ctr" rotWithShape="0">
+                    <a:srgbClr val="6E747A">
+                      <a:alpha val="43000"/>
+                    </a:srgbClr>
+                  </a:outerShdw>
+                </a:effectLst>
+              </a:rPr>
+              <a:t>हो</a:t>
+            </a:r>
+            <a:r>
+              <a:rPr lang="en-IN" sz="1000" dirty="0">
+                <a:ln w="0"/>
+                <a:solidFill>
+                  <a:schemeClr val="accent1"/>
+                </a:solidFill>
+                <a:effectLst>
+                  <a:outerShdw blurRad="38100" dist="25400" dir="5400000" algn="ctr" rotWithShape="0">
+                    <a:srgbClr val="6E747A">
+                      <a:alpha val="43000"/>
+                    </a:srgbClr>
+                  </a:outerShdw>
+                </a:effectLst>
+              </a:rPr>
+              <a:t> </a:t>
+            </a:r>
+            <a:r>
+              <a:rPr lang="en-IN" sz="1000" dirty="0" err="1">
+                <a:ln w="0"/>
+                <a:solidFill>
+                  <a:schemeClr val="accent1"/>
+                </a:solidFill>
+                <a:effectLst>
+                  <a:outerShdw blurRad="38100" dist="25400" dir="5400000" algn="ctr" rotWithShape="0">
+                    <a:srgbClr val="6E747A">
+                      <a:alpha val="43000"/>
+                    </a:srgbClr>
+                  </a:outerShdw>
+                </a:effectLst>
+              </a:rPr>
+              <a:t>चुकी</a:t>
+            </a:r>
+            <a:r>
+              <a:rPr lang="en-IN" sz="1000" dirty="0">
+                <a:ln w="0"/>
+                <a:solidFill>
+                  <a:schemeClr val="accent1"/>
+                </a:solidFill>
+                <a:effectLst>
+                  <a:outerShdw blurRad="38100" dist="25400" dir="5400000" algn="ctr" rotWithShape="0">
+                    <a:srgbClr val="6E747A">
+                      <a:alpha val="43000"/>
+                    </a:srgbClr>
+                  </a:outerShdw>
+                </a:effectLst>
+              </a:rPr>
+              <a:t> </a:t>
+            </a:r>
+            <a:r>
+              <a:rPr lang="en-IN" sz="1000" dirty="0" err="1">
+                <a:ln w="0"/>
+                <a:solidFill>
+                  <a:schemeClr val="accent1"/>
+                </a:solidFill>
+                <a:effectLst>
+                  <a:outerShdw blurRad="38100" dist="25400" dir="5400000" algn="ctr" rotWithShape="0">
+                    <a:srgbClr val="6E747A">
+                      <a:alpha val="43000"/>
+                    </a:srgbClr>
+                  </a:outerShdw>
+                </a:effectLst>
+              </a:rPr>
+              <a:t>है</a:t>
+            </a:r>
+            <a:r>
+              <a:rPr lang="en-IN" sz="1000" dirty="0">
+                <a:ln w="0"/>
+                <a:solidFill>
+                  <a:schemeClr val="accent1"/>
+                </a:solidFill>
+                <a:effectLst>
+                  <a:outerShdw blurRad="38100" dist="25400" dir="5400000" algn="ctr" rotWithShape="0">
+                    <a:srgbClr val="6E747A">
+                      <a:alpha val="43000"/>
+                    </a:srgbClr>
+                  </a:outerShdw>
+                </a:effectLst>
+              </a:rPr>
+              <a:t>। </a:t>
+            </a:r>
+            <a:r>
+              <a:rPr lang="en-IN" sz="1000" dirty="0" err="1">
+                <a:ln w="0"/>
+                <a:solidFill>
+                  <a:schemeClr val="accent1"/>
+                </a:solidFill>
+                <a:effectLst>
+                  <a:outerShdw blurRad="38100" dist="25400" dir="5400000" algn="ctr" rotWithShape="0">
+                    <a:srgbClr val="6E747A">
+                      <a:alpha val="43000"/>
+                    </a:srgbClr>
+                  </a:outerShdw>
+                </a:effectLst>
+              </a:rPr>
+              <a:t>अमरीकी</a:t>
+            </a:r>
+            <a:r>
+              <a:rPr lang="en-IN" sz="1000" dirty="0">
+                <a:ln w="0"/>
+                <a:solidFill>
+                  <a:schemeClr val="accent1"/>
+                </a:solidFill>
+                <a:effectLst>
+                  <a:outerShdw blurRad="38100" dist="25400" dir="5400000" algn="ctr" rotWithShape="0">
+                    <a:srgbClr val="6E747A">
+                      <a:alpha val="43000"/>
+                    </a:srgbClr>
+                  </a:outerShdw>
+                </a:effectLst>
+              </a:rPr>
+              <a:t> </a:t>
+            </a:r>
+            <a:r>
+              <a:rPr lang="en-IN" sz="1000" dirty="0" err="1">
+                <a:ln w="0"/>
+                <a:solidFill>
+                  <a:schemeClr val="accent1"/>
+                </a:solidFill>
+                <a:effectLst>
+                  <a:outerShdw blurRad="38100" dist="25400" dir="5400000" algn="ctr" rotWithShape="0">
+                    <a:srgbClr val="6E747A">
+                      <a:alpha val="43000"/>
+                    </a:srgbClr>
+                  </a:outerShdw>
+                </a:effectLst>
+              </a:rPr>
+              <a:t>वैज्ञानिकों</a:t>
+            </a:r>
+            <a:r>
+              <a:rPr lang="en-IN" sz="1000" dirty="0">
+                <a:ln w="0"/>
+                <a:solidFill>
+                  <a:schemeClr val="accent1"/>
+                </a:solidFill>
+                <a:effectLst>
+                  <a:outerShdw blurRad="38100" dist="25400" dir="5400000" algn="ctr" rotWithShape="0">
+                    <a:srgbClr val="6E747A">
+                      <a:alpha val="43000"/>
+                    </a:srgbClr>
+                  </a:outerShdw>
+                </a:effectLst>
+              </a:rPr>
+              <a:t> </a:t>
+            </a:r>
+            <a:r>
+              <a:rPr lang="en-IN" sz="1000" dirty="0" err="1">
+                <a:ln w="0"/>
+                <a:solidFill>
+                  <a:schemeClr val="accent1"/>
+                </a:solidFill>
+                <a:effectLst>
+                  <a:outerShdw blurRad="38100" dist="25400" dir="5400000" algn="ctr" rotWithShape="0">
+                    <a:srgbClr val="6E747A">
+                      <a:alpha val="43000"/>
+                    </a:srgbClr>
+                  </a:outerShdw>
+                </a:effectLst>
+              </a:rPr>
+              <a:t>ने</a:t>
+            </a:r>
+            <a:r>
+              <a:rPr lang="en-IN" sz="1000" dirty="0">
+                <a:ln w="0"/>
+                <a:solidFill>
+                  <a:schemeClr val="accent1"/>
+                </a:solidFill>
+                <a:effectLst>
+                  <a:outerShdw blurRad="38100" dist="25400" dir="5400000" algn="ctr" rotWithShape="0">
+                    <a:srgbClr val="6E747A">
+                      <a:alpha val="43000"/>
+                    </a:srgbClr>
+                  </a:outerShdw>
+                </a:effectLst>
+              </a:rPr>
+              <a:t> </a:t>
+            </a:r>
+            <a:r>
+              <a:rPr lang="en-IN" sz="1000" dirty="0" err="1">
+                <a:ln w="0"/>
+                <a:solidFill>
+                  <a:schemeClr val="accent1"/>
+                </a:solidFill>
+                <a:effectLst>
+                  <a:outerShdw blurRad="38100" dist="25400" dir="5400000" algn="ctr" rotWithShape="0">
+                    <a:srgbClr val="6E747A">
+                      <a:alpha val="43000"/>
+                    </a:srgbClr>
+                  </a:outerShdw>
+                </a:effectLst>
+              </a:rPr>
+              <a:t>पुष्टि</a:t>
+            </a:r>
+            <a:r>
+              <a:rPr lang="en-IN" sz="1000" dirty="0">
+                <a:ln w="0"/>
+                <a:solidFill>
+                  <a:schemeClr val="accent1"/>
+                </a:solidFill>
+                <a:effectLst>
+                  <a:outerShdw blurRad="38100" dist="25400" dir="5400000" algn="ctr" rotWithShape="0">
+                    <a:srgbClr val="6E747A">
+                      <a:alpha val="43000"/>
+                    </a:srgbClr>
+                  </a:outerShdw>
+                </a:effectLst>
+              </a:rPr>
+              <a:t> </a:t>
+            </a:r>
+            <a:r>
+              <a:rPr lang="en-IN" sz="1000" dirty="0" err="1">
+                <a:ln w="0"/>
+                <a:solidFill>
+                  <a:schemeClr val="accent1"/>
+                </a:solidFill>
+                <a:effectLst>
+                  <a:outerShdw blurRad="38100" dist="25400" dir="5400000" algn="ctr" rotWithShape="0">
+                    <a:srgbClr val="6E747A">
+                      <a:alpha val="43000"/>
+                    </a:srgbClr>
+                  </a:outerShdw>
+                </a:effectLst>
+              </a:rPr>
+              <a:t>की</a:t>
+            </a:r>
+            <a:r>
+              <a:rPr lang="en-IN" sz="1000" dirty="0">
+                <a:ln w="0"/>
+                <a:solidFill>
+                  <a:schemeClr val="accent1"/>
+                </a:solidFill>
+                <a:effectLst>
+                  <a:outerShdw blurRad="38100" dist="25400" dir="5400000" algn="ctr" rotWithShape="0">
+                    <a:srgbClr val="6E747A">
+                      <a:alpha val="43000"/>
+                    </a:srgbClr>
+                  </a:outerShdw>
+                </a:effectLst>
+              </a:rPr>
+              <a:t> </a:t>
+            </a:r>
+            <a:r>
+              <a:rPr lang="en-IN" sz="1000" dirty="0" err="1">
+                <a:ln w="0"/>
+                <a:solidFill>
+                  <a:schemeClr val="accent1"/>
+                </a:solidFill>
+                <a:effectLst>
+                  <a:outerShdw blurRad="38100" dist="25400" dir="5400000" algn="ctr" rotWithShape="0">
+                    <a:srgbClr val="6E747A">
+                      <a:alpha val="43000"/>
+                    </a:srgbClr>
+                  </a:outerShdw>
+                </a:effectLst>
+              </a:rPr>
+              <a:t>है</a:t>
+            </a:r>
+            <a:r>
+              <a:rPr lang="en-IN" sz="1000" dirty="0">
+                <a:ln w="0"/>
+                <a:solidFill>
+                  <a:schemeClr val="accent1"/>
+                </a:solidFill>
+                <a:effectLst>
+                  <a:outerShdw blurRad="38100" dist="25400" dir="5400000" algn="ctr" rotWithShape="0">
+                    <a:srgbClr val="6E747A">
+                      <a:alpha val="43000"/>
+                    </a:srgbClr>
+                  </a:outerShdw>
+                </a:effectLst>
+              </a:rPr>
+              <a:t> </a:t>
+            </a:r>
+            <a:r>
+              <a:rPr lang="en-IN" sz="1000" dirty="0" err="1">
+                <a:ln w="0"/>
+                <a:solidFill>
+                  <a:schemeClr val="accent1"/>
+                </a:solidFill>
+                <a:effectLst>
+                  <a:outerShdw blurRad="38100" dist="25400" dir="5400000" algn="ctr" rotWithShape="0">
+                    <a:srgbClr val="6E747A">
+                      <a:alpha val="43000"/>
+                    </a:srgbClr>
+                  </a:outerShdw>
+                </a:effectLst>
+              </a:rPr>
+              <a:t>कि</a:t>
+            </a:r>
+            <a:r>
+              <a:rPr lang="en-IN" sz="1000" dirty="0">
+                <a:ln w="0"/>
+                <a:solidFill>
+                  <a:schemeClr val="accent1"/>
+                </a:solidFill>
+                <a:effectLst>
+                  <a:outerShdw blurRad="38100" dist="25400" dir="5400000" algn="ctr" rotWithShape="0">
+                    <a:srgbClr val="6E747A">
+                      <a:alpha val="43000"/>
+                    </a:srgbClr>
+                  </a:outerShdw>
+                </a:effectLst>
+              </a:rPr>
+              <a:t> एच5एन1 </a:t>
+            </a:r>
+            <a:r>
+              <a:rPr lang="en-IN" sz="1000" dirty="0" err="1">
+                <a:ln w="0"/>
+                <a:solidFill>
+                  <a:schemeClr val="accent1"/>
+                </a:solidFill>
+                <a:effectLst>
+                  <a:outerShdw blurRad="38100" dist="25400" dir="5400000" algn="ctr" rotWithShape="0">
+                    <a:srgbClr val="6E747A">
+                      <a:alpha val="43000"/>
+                    </a:srgbClr>
+                  </a:outerShdw>
+                </a:effectLst>
+              </a:rPr>
+              <a:t>वायरस</a:t>
+            </a:r>
+            <a:r>
+              <a:rPr lang="en-IN" sz="1000" dirty="0">
+                <a:ln w="0"/>
+                <a:solidFill>
+                  <a:schemeClr val="accent1"/>
+                </a:solidFill>
+                <a:effectLst>
+                  <a:outerShdw blurRad="38100" dist="25400" dir="5400000" algn="ctr" rotWithShape="0">
+                    <a:srgbClr val="6E747A">
+                      <a:alpha val="43000"/>
+                    </a:srgbClr>
+                  </a:outerShdw>
+                </a:effectLst>
+              </a:rPr>
+              <a:t> </a:t>
+            </a:r>
+            <a:r>
+              <a:rPr lang="en-IN" sz="1000" dirty="0" err="1">
+                <a:ln w="0"/>
+                <a:solidFill>
+                  <a:schemeClr val="accent1"/>
+                </a:solidFill>
+                <a:effectLst>
+                  <a:outerShdw blurRad="38100" dist="25400" dir="5400000" algn="ctr" rotWithShape="0">
+                    <a:srgbClr val="6E747A">
+                      <a:alpha val="43000"/>
+                    </a:srgbClr>
+                  </a:outerShdw>
+                </a:effectLst>
+              </a:rPr>
+              <a:t>दो</a:t>
+            </a:r>
+            <a:r>
+              <a:rPr lang="en-IN" sz="1000" dirty="0">
+                <a:ln w="0"/>
+                <a:solidFill>
+                  <a:schemeClr val="accent1"/>
+                </a:solidFill>
+                <a:effectLst>
+                  <a:outerShdw blurRad="38100" dist="25400" dir="5400000" algn="ctr" rotWithShape="0">
+                    <a:srgbClr val="6E747A">
+                      <a:alpha val="43000"/>
+                    </a:srgbClr>
+                  </a:outerShdw>
+                </a:effectLst>
+              </a:rPr>
+              <a:t> </a:t>
+            </a:r>
+            <a:r>
+              <a:rPr lang="en-IN" sz="1000" dirty="0" err="1">
+                <a:ln w="0"/>
+                <a:solidFill>
+                  <a:schemeClr val="accent1"/>
+                </a:solidFill>
+                <a:effectLst>
+                  <a:outerShdw blurRad="38100" dist="25400" dir="5400000" algn="ctr" rotWithShape="0">
+                    <a:srgbClr val="6E747A">
+                      <a:alpha val="43000"/>
+                    </a:srgbClr>
+                  </a:outerShdw>
+                </a:effectLst>
+              </a:rPr>
+              <a:t>अलग</a:t>
+            </a:r>
+            <a:r>
+              <a:rPr lang="en-IN" sz="1000" dirty="0">
+                <a:ln w="0"/>
+                <a:solidFill>
+                  <a:schemeClr val="accent1"/>
+                </a:solidFill>
+                <a:effectLst>
+                  <a:outerShdw blurRad="38100" dist="25400" dir="5400000" algn="ctr" rotWithShape="0">
+                    <a:srgbClr val="6E747A">
+                      <a:alpha val="43000"/>
+                    </a:srgbClr>
+                  </a:outerShdw>
+                </a:effectLst>
+              </a:rPr>
+              <a:t> </a:t>
+            </a:r>
+            <a:r>
+              <a:rPr lang="en-IN" sz="1000" dirty="0" err="1">
+                <a:ln w="0"/>
+                <a:solidFill>
+                  <a:schemeClr val="accent1"/>
+                </a:solidFill>
+                <a:effectLst>
+                  <a:outerShdw blurRad="38100" dist="25400" dir="5400000" algn="ctr" rotWithShape="0">
+                    <a:srgbClr val="6E747A">
+                      <a:alpha val="43000"/>
+                    </a:srgbClr>
+                  </a:outerShdw>
+                </a:effectLst>
+              </a:rPr>
+              <a:t>विषाणुओं</a:t>
+            </a:r>
+            <a:r>
+              <a:rPr lang="en-IN" sz="1000" dirty="0">
+                <a:ln w="0"/>
+                <a:solidFill>
+                  <a:schemeClr val="accent1"/>
+                </a:solidFill>
+                <a:effectLst>
+                  <a:outerShdw blurRad="38100" dist="25400" dir="5400000" algn="ctr" rotWithShape="0">
+                    <a:srgbClr val="6E747A">
+                      <a:alpha val="43000"/>
+                    </a:srgbClr>
+                  </a:outerShdw>
+                </a:effectLst>
+              </a:rPr>
+              <a:t> </a:t>
+            </a:r>
+            <a:r>
+              <a:rPr lang="en-IN" sz="1000" dirty="0" err="1">
+                <a:ln w="0"/>
+                <a:solidFill>
+                  <a:schemeClr val="accent1"/>
+                </a:solidFill>
+                <a:effectLst>
+                  <a:outerShdw blurRad="38100" dist="25400" dir="5400000" algn="ctr" rotWithShape="0">
+                    <a:srgbClr val="6E747A">
+                      <a:alpha val="43000"/>
+                    </a:srgbClr>
+                  </a:outerShdw>
+                </a:effectLst>
+              </a:rPr>
+              <a:t>में</a:t>
+            </a:r>
+            <a:r>
+              <a:rPr lang="en-IN" sz="1000" dirty="0">
+                <a:ln w="0"/>
+                <a:solidFill>
+                  <a:schemeClr val="accent1"/>
+                </a:solidFill>
+                <a:effectLst>
+                  <a:outerShdw blurRad="38100" dist="25400" dir="5400000" algn="ctr" rotWithShape="0">
+                    <a:srgbClr val="6E747A">
+                      <a:alpha val="43000"/>
+                    </a:srgbClr>
+                  </a:outerShdw>
+                </a:effectLst>
+              </a:rPr>
+              <a:t> </a:t>
+            </a:r>
+            <a:r>
+              <a:rPr lang="en-IN" sz="1000" dirty="0" err="1">
+                <a:ln w="0"/>
+                <a:solidFill>
+                  <a:schemeClr val="accent1"/>
+                </a:solidFill>
+                <a:effectLst>
+                  <a:outerShdw blurRad="38100" dist="25400" dir="5400000" algn="ctr" rotWithShape="0">
+                    <a:srgbClr val="6E747A">
+                      <a:alpha val="43000"/>
+                    </a:srgbClr>
+                  </a:outerShdw>
+                </a:effectLst>
+              </a:rPr>
+              <a:t>बदल</a:t>
+            </a:r>
+            <a:r>
+              <a:rPr lang="en-IN" sz="1000" dirty="0">
+                <a:ln w="0"/>
+                <a:solidFill>
+                  <a:schemeClr val="accent1"/>
+                </a:solidFill>
+                <a:effectLst>
+                  <a:outerShdw blurRad="38100" dist="25400" dir="5400000" algn="ctr" rotWithShape="0">
+                    <a:srgbClr val="6E747A">
+                      <a:alpha val="43000"/>
+                    </a:srgbClr>
+                  </a:outerShdw>
+                </a:effectLst>
+              </a:rPr>
+              <a:t> </a:t>
+            </a:r>
+            <a:r>
+              <a:rPr lang="en-IN" sz="1000" dirty="0" err="1">
+                <a:ln w="0"/>
+                <a:solidFill>
+                  <a:schemeClr val="accent1"/>
+                </a:solidFill>
+                <a:effectLst>
+                  <a:outerShdw blurRad="38100" dist="25400" dir="5400000" algn="ctr" rotWithShape="0">
+                    <a:srgbClr val="6E747A">
+                      <a:alpha val="43000"/>
+                    </a:srgbClr>
+                  </a:outerShdw>
+                </a:effectLst>
+              </a:rPr>
+              <a:t>चुका</a:t>
+            </a:r>
+            <a:r>
+              <a:rPr lang="en-IN" sz="1000" dirty="0">
+                <a:ln w="0"/>
+                <a:solidFill>
+                  <a:schemeClr val="accent1"/>
+                </a:solidFill>
+                <a:effectLst>
+                  <a:outerShdw blurRad="38100" dist="25400" dir="5400000" algn="ctr" rotWithShape="0">
+                    <a:srgbClr val="6E747A">
+                      <a:alpha val="43000"/>
+                    </a:srgbClr>
+                  </a:outerShdw>
+                </a:effectLst>
+              </a:rPr>
+              <a:t> </a:t>
+            </a:r>
+            <a:r>
+              <a:rPr lang="en-IN" sz="1000" dirty="0" err="1">
+                <a:ln w="0"/>
+                <a:solidFill>
+                  <a:schemeClr val="accent1"/>
+                </a:solidFill>
+                <a:effectLst>
+                  <a:outerShdw blurRad="38100" dist="25400" dir="5400000" algn="ctr" rotWithShape="0">
+                    <a:srgbClr val="6E747A">
+                      <a:alpha val="43000"/>
+                    </a:srgbClr>
+                  </a:outerShdw>
+                </a:effectLst>
+              </a:rPr>
+              <a:t>है</a:t>
+            </a:r>
+            <a:r>
+              <a:rPr lang="en-IN" sz="1000" dirty="0">
+                <a:ln w="0"/>
+                <a:solidFill>
+                  <a:schemeClr val="accent1"/>
+                </a:solidFill>
+                <a:effectLst>
+                  <a:outerShdw blurRad="38100" dist="25400" dir="5400000" algn="ctr" rotWithShape="0">
+                    <a:srgbClr val="6E747A">
+                      <a:alpha val="43000"/>
+                    </a:srgbClr>
+                  </a:outerShdw>
+                </a:effectLst>
+              </a:rPr>
+              <a:t>, </a:t>
+            </a:r>
+            <a:r>
+              <a:rPr lang="en-IN" sz="1000" dirty="0" err="1">
+                <a:ln w="0"/>
+                <a:solidFill>
+                  <a:schemeClr val="accent1"/>
+                </a:solidFill>
+                <a:effectLst>
+                  <a:outerShdw blurRad="38100" dist="25400" dir="5400000" algn="ctr" rotWithShape="0">
+                    <a:srgbClr val="6E747A">
+                      <a:alpha val="43000"/>
+                    </a:srgbClr>
+                  </a:outerShdw>
+                </a:effectLst>
+              </a:rPr>
+              <a:t>जिससे</a:t>
+            </a:r>
+            <a:r>
+              <a:rPr lang="en-IN" sz="1000" dirty="0">
+                <a:ln w="0"/>
+                <a:solidFill>
+                  <a:schemeClr val="accent1"/>
+                </a:solidFill>
+                <a:effectLst>
+                  <a:outerShdw blurRad="38100" dist="25400" dir="5400000" algn="ctr" rotWithShape="0">
+                    <a:srgbClr val="6E747A">
+                      <a:alpha val="43000"/>
+                    </a:srgbClr>
+                  </a:outerShdw>
+                </a:effectLst>
+              </a:rPr>
+              <a:t> </a:t>
+            </a:r>
+            <a:r>
+              <a:rPr lang="en-IN" sz="1000" dirty="0" err="1">
+                <a:ln w="0"/>
+                <a:solidFill>
+                  <a:schemeClr val="accent1"/>
+                </a:solidFill>
+                <a:effectLst>
+                  <a:outerShdw blurRad="38100" dist="25400" dir="5400000" algn="ctr" rotWithShape="0">
+                    <a:srgbClr val="6E747A">
+                      <a:alpha val="43000"/>
+                    </a:srgbClr>
+                  </a:outerShdw>
+                </a:effectLst>
+              </a:rPr>
+              <a:t>मनुष्यों</a:t>
+            </a:r>
+            <a:r>
+              <a:rPr lang="en-IN" sz="1000" dirty="0">
+                <a:ln w="0"/>
+                <a:solidFill>
+                  <a:schemeClr val="accent1"/>
+                </a:solidFill>
+                <a:effectLst>
+                  <a:outerShdw blurRad="38100" dist="25400" dir="5400000" algn="ctr" rotWithShape="0">
+                    <a:srgbClr val="6E747A">
+                      <a:alpha val="43000"/>
+                    </a:srgbClr>
+                  </a:outerShdw>
+                </a:effectLst>
+              </a:rPr>
+              <a:t> </a:t>
+            </a:r>
+            <a:r>
+              <a:rPr lang="en-IN" sz="1000" dirty="0" err="1">
+                <a:ln w="0"/>
+                <a:solidFill>
+                  <a:schemeClr val="accent1"/>
+                </a:solidFill>
+                <a:effectLst>
+                  <a:outerShdw blurRad="38100" dist="25400" dir="5400000" algn="ctr" rotWithShape="0">
+                    <a:srgbClr val="6E747A">
+                      <a:alpha val="43000"/>
+                    </a:srgbClr>
+                  </a:outerShdw>
+                </a:effectLst>
+              </a:rPr>
+              <a:t>के</a:t>
+            </a:r>
+            <a:r>
+              <a:rPr lang="en-IN" sz="1000" dirty="0">
+                <a:ln w="0"/>
+                <a:solidFill>
+                  <a:schemeClr val="accent1"/>
+                </a:solidFill>
+                <a:effectLst>
+                  <a:outerShdw blurRad="38100" dist="25400" dir="5400000" algn="ctr" rotWithShape="0">
+                    <a:srgbClr val="6E747A">
+                      <a:alpha val="43000"/>
+                    </a:srgbClr>
+                  </a:outerShdw>
+                </a:effectLst>
+              </a:rPr>
+              <a:t> </a:t>
+            </a:r>
+            <a:r>
+              <a:rPr lang="en-IN" sz="1000" dirty="0" err="1">
+                <a:ln w="0"/>
+                <a:solidFill>
+                  <a:schemeClr val="accent1"/>
+                </a:solidFill>
+                <a:effectLst>
+                  <a:outerShdw blurRad="38100" dist="25400" dir="5400000" algn="ctr" rotWithShape="0">
+                    <a:srgbClr val="6E747A">
+                      <a:alpha val="43000"/>
+                    </a:srgbClr>
+                  </a:outerShdw>
+                </a:effectLst>
+              </a:rPr>
+              <a:t>लिए</a:t>
+            </a:r>
+            <a:r>
+              <a:rPr lang="en-IN" sz="1000" dirty="0">
+                <a:ln w="0"/>
+                <a:solidFill>
+                  <a:schemeClr val="accent1"/>
+                </a:solidFill>
+                <a:effectLst>
+                  <a:outerShdw blurRad="38100" dist="25400" dir="5400000" algn="ctr" rotWithShape="0">
+                    <a:srgbClr val="6E747A">
+                      <a:alpha val="43000"/>
+                    </a:srgbClr>
+                  </a:outerShdw>
+                </a:effectLst>
+              </a:rPr>
+              <a:t> </a:t>
+            </a:r>
+            <a:r>
+              <a:rPr lang="en-IN" sz="1000" dirty="0" err="1">
+                <a:ln w="0"/>
+                <a:solidFill>
+                  <a:schemeClr val="accent1"/>
+                </a:solidFill>
+                <a:effectLst>
+                  <a:outerShdw blurRad="38100" dist="25400" dir="5400000" algn="ctr" rotWithShape="0">
+                    <a:srgbClr val="6E747A">
+                      <a:alpha val="43000"/>
+                    </a:srgbClr>
+                  </a:outerShdw>
+                </a:effectLst>
+              </a:rPr>
+              <a:t>खतरा</a:t>
+            </a:r>
+            <a:r>
+              <a:rPr lang="en-IN" sz="1000" dirty="0">
+                <a:ln w="0"/>
+                <a:solidFill>
+                  <a:schemeClr val="accent1"/>
+                </a:solidFill>
+                <a:effectLst>
+                  <a:outerShdw blurRad="38100" dist="25400" dir="5400000" algn="ctr" rotWithShape="0">
+                    <a:srgbClr val="6E747A">
+                      <a:alpha val="43000"/>
+                    </a:srgbClr>
+                  </a:outerShdw>
+                </a:effectLst>
+              </a:rPr>
+              <a:t> </a:t>
+            </a:r>
+            <a:r>
+              <a:rPr lang="en-IN" sz="1000" dirty="0" err="1">
+                <a:ln w="0"/>
+                <a:solidFill>
+                  <a:schemeClr val="accent1"/>
+                </a:solidFill>
+                <a:effectLst>
+                  <a:outerShdw blurRad="38100" dist="25400" dir="5400000" algn="ctr" rotWithShape="0">
+                    <a:srgbClr val="6E747A">
+                      <a:alpha val="43000"/>
+                    </a:srgbClr>
+                  </a:outerShdw>
+                </a:effectLst>
+              </a:rPr>
+              <a:t>बढ़</a:t>
+            </a:r>
+            <a:r>
+              <a:rPr lang="en-IN" sz="1000" dirty="0">
+                <a:ln w="0"/>
+                <a:solidFill>
+                  <a:schemeClr val="accent1"/>
+                </a:solidFill>
+                <a:effectLst>
+                  <a:outerShdw blurRad="38100" dist="25400" dir="5400000" algn="ctr" rotWithShape="0">
+                    <a:srgbClr val="6E747A">
+                      <a:alpha val="43000"/>
+                    </a:srgbClr>
+                  </a:outerShdw>
+                </a:effectLst>
+              </a:rPr>
+              <a:t> </a:t>
+            </a:r>
+            <a:r>
+              <a:rPr lang="en-IN" sz="1000" dirty="0" err="1">
+                <a:ln w="0"/>
+                <a:solidFill>
+                  <a:schemeClr val="accent1"/>
+                </a:solidFill>
+                <a:effectLst>
+                  <a:outerShdw blurRad="38100" dist="25400" dir="5400000" algn="ctr" rotWithShape="0">
+                    <a:srgbClr val="6E747A">
+                      <a:alpha val="43000"/>
+                    </a:srgbClr>
+                  </a:outerShdw>
+                </a:effectLst>
+              </a:rPr>
+              <a:t>गया</a:t>
+            </a:r>
+            <a:r>
+              <a:rPr lang="en-IN" sz="1000" dirty="0">
+                <a:ln w="0"/>
+                <a:solidFill>
+                  <a:schemeClr val="accent1"/>
+                </a:solidFill>
+                <a:effectLst>
+                  <a:outerShdw blurRad="38100" dist="25400" dir="5400000" algn="ctr" rotWithShape="0">
+                    <a:srgbClr val="6E747A">
+                      <a:alpha val="43000"/>
+                    </a:srgbClr>
+                  </a:outerShdw>
+                </a:effectLst>
+              </a:rPr>
+              <a:t> </a:t>
+            </a:r>
+            <a:r>
+              <a:rPr lang="en-IN" sz="1000" dirty="0" err="1">
+                <a:ln w="0"/>
+                <a:solidFill>
+                  <a:schemeClr val="accent1"/>
+                </a:solidFill>
+                <a:effectLst>
+                  <a:outerShdw blurRad="38100" dist="25400" dir="5400000" algn="ctr" rotWithShape="0">
+                    <a:srgbClr val="6E747A">
+                      <a:alpha val="43000"/>
+                    </a:srgbClr>
+                  </a:outerShdw>
+                </a:effectLst>
+              </a:rPr>
+              <a:t>है</a:t>
+            </a:r>
+            <a:r>
+              <a:rPr lang="en-IN" sz="1000" dirty="0">
+                <a:ln w="0"/>
+                <a:solidFill>
+                  <a:schemeClr val="accent1"/>
+                </a:solidFill>
+                <a:effectLst>
+                  <a:outerShdw blurRad="38100" dist="25400" dir="5400000" algn="ctr" rotWithShape="0">
+                    <a:srgbClr val="6E747A">
+                      <a:alpha val="43000"/>
+                    </a:srgbClr>
+                  </a:outerShdw>
+                </a:effectLst>
+              </a:rPr>
+              <a:t>।</a:t>
+            </a:r>
+            <a:endParaRPr lang="en-US" sz="1000" dirty="0"/>
           </a:p>
         </p:txBody>
       </p:sp>
@@ -10488,7 +13236,7 @@
         </p:nvSpPr>
         <p:spPr>
           <a:xfrm>
-            <a:off x="6583680" y="4206240"/>
+            <a:off x="6629400" y="5073257"/>
             <a:ext cx="4846320" cy="1051560"/>
           </a:xfrm>
           <a:prstGeom prst="roundRect">
@@ -10510,7 +13258,7 @@
         </p:nvSpPr>
         <p:spPr>
           <a:xfrm>
-            <a:off x="6720840" y="4279392"/>
+            <a:off x="6835140" y="5256137"/>
             <a:ext cx="4572000" cy="914400"/>
           </a:xfrm>
           <a:prstGeom prst="rect">
@@ -10523,14 +13271,13 @@
           <a:bodyPr wrap="square" rtlCol="0" anchor="t"/>
           <a:lstStyle/>
           <a:p>
-            <a:pPr marL="0" indent="0">
+            <a:pPr>
               <a:lnSpc>
                 <a:spcPct val="110000"/>
               </a:lnSpc>
-              <a:buNone/>
             </a:pPr>
             <a:r>
-              <a:rPr lang="en-US" sz="950" dirty="0">
+              <a:rPr lang="en-US" sz="1000" dirty="0">
                 <a:solidFill>
                   <a:srgbClr val="FFFFFF"/>
                 </a:solidFill>
@@ -10538,9 +13285,664 @@
                 <a:ea typeface="Calibri" pitchFamily="34" charset="-122"/>
                 <a:cs typeface="Calibri" pitchFamily="34" charset="-120"/>
               </a:rPr>
-              <a:t>Compressed (44 tokens, KEEP tokens only): WHO, bird flu, H5N1 virus, US scientists confirmed, H5N1 virus, two strains, split, humans, risk increased.</a:t>
-            </a:r>
-            <a:endParaRPr lang="en-US" sz="950" dirty="0"/>
+              <a:t>Compressed</a:t>
+            </a:r>
+            <a:r>
+              <a:rPr lang="en-US" sz="1000" dirty="0">
+                <a:solidFill>
+                  <a:srgbClr val="FFFFFF"/>
+                </a:solidFill>
+                <a:latin typeface="Calibri" pitchFamily="34" charset="0"/>
+                <a:ea typeface="Calibri" pitchFamily="34" charset="-122"/>
+                <a:cs typeface="Calibri" pitchFamily="34" charset="-120"/>
+                <a:sym typeface="Wingdings" panose="05000000000000000000" pitchFamily="2" charset="2"/>
+              </a:rPr>
+              <a:t>(44tokens 42.5 compression ratio)</a:t>
+            </a:r>
+            <a:r>
+              <a:rPr lang="en-US" sz="1000" b="1" spc="50" dirty="0">
+                <a:ln w="0"/>
+                <a:solidFill>
+                  <a:schemeClr val="bg2"/>
+                </a:solidFill>
+                <a:effectLst>
+                  <a:innerShdw blurRad="63500" dist="50800" dir="13500000">
+                    <a:srgbClr val="000000">
+                      <a:alpha val="50000"/>
+                    </a:srgbClr>
+                  </a:innerShdw>
+                </a:effectLst>
+                <a:latin typeface="Calibri" pitchFamily="34" charset="0"/>
+                <a:ea typeface="Calibri" pitchFamily="34" charset="-122"/>
+                <a:cs typeface="Calibri" pitchFamily="34" charset="-120"/>
+              </a:rPr>
+              <a:t> </a:t>
+            </a:r>
+            <a:r>
+              <a:rPr lang="en-IN" sz="1000" b="1" spc="50" dirty="0" err="1">
+                <a:ln w="0"/>
+                <a:solidFill>
+                  <a:schemeClr val="bg2"/>
+                </a:solidFill>
+                <a:effectLst>
+                  <a:innerShdw blurRad="63500" dist="50800" dir="13500000">
+                    <a:srgbClr val="000000">
+                      <a:alpha val="50000"/>
+                    </a:srgbClr>
+                  </a:innerShdw>
+                </a:effectLst>
+              </a:rPr>
+              <a:t>विश्व</a:t>
+            </a:r>
+            <a:r>
+              <a:rPr lang="en-IN" sz="1000" b="1" spc="50" dirty="0">
+                <a:ln w="0"/>
+                <a:solidFill>
+                  <a:schemeClr val="bg2"/>
+                </a:solidFill>
+                <a:effectLst>
+                  <a:innerShdw blurRad="63500" dist="50800" dir="13500000">
+                    <a:srgbClr val="000000">
+                      <a:alpha val="50000"/>
+                    </a:srgbClr>
+                  </a:innerShdw>
+                </a:effectLst>
+              </a:rPr>
+              <a:t> </a:t>
+            </a:r>
+            <a:r>
+              <a:rPr lang="en-IN" sz="1000" b="1" spc="50" dirty="0" err="1">
+                <a:ln w="0"/>
+                <a:solidFill>
+                  <a:schemeClr val="bg2"/>
+                </a:solidFill>
+                <a:effectLst>
+                  <a:innerShdw blurRad="63500" dist="50800" dir="13500000">
+                    <a:srgbClr val="000000">
+                      <a:alpha val="50000"/>
+                    </a:srgbClr>
+                  </a:innerShdw>
+                </a:effectLst>
+              </a:rPr>
+              <a:t>स्वास्थ्य</a:t>
+            </a:r>
+            <a:r>
+              <a:rPr lang="en-IN" sz="1000" b="1" spc="50" dirty="0">
+                <a:ln w="0"/>
+                <a:solidFill>
+                  <a:schemeClr val="bg2"/>
+                </a:solidFill>
+                <a:effectLst>
+                  <a:innerShdw blurRad="63500" dist="50800" dir="13500000">
+                    <a:srgbClr val="000000">
+                      <a:alpha val="50000"/>
+                    </a:srgbClr>
+                  </a:innerShdw>
+                </a:effectLst>
+              </a:rPr>
+              <a:t> </a:t>
+            </a:r>
+            <a:r>
+              <a:rPr lang="en-IN" sz="1000" b="1" spc="50" dirty="0" err="1">
+                <a:ln w="0"/>
+                <a:solidFill>
+                  <a:schemeClr val="bg2"/>
+                </a:solidFill>
+                <a:effectLst>
+                  <a:innerShdw blurRad="63500" dist="50800" dir="13500000">
+                    <a:srgbClr val="000000">
+                      <a:alpha val="50000"/>
+                    </a:srgbClr>
+                  </a:innerShdw>
+                </a:effectLst>
+              </a:rPr>
+              <a:t>संगठन</a:t>
+            </a:r>
+            <a:r>
+              <a:rPr lang="en-IN" sz="1000" b="1" spc="50" dirty="0">
+                <a:ln w="0"/>
+                <a:solidFill>
+                  <a:schemeClr val="bg2"/>
+                </a:solidFill>
+                <a:effectLst>
+                  <a:innerShdw blurRad="63500" dist="50800" dir="13500000">
+                    <a:srgbClr val="000000">
+                      <a:alpha val="50000"/>
+                    </a:srgbClr>
+                  </a:innerShdw>
+                </a:effectLst>
+              </a:rPr>
+              <a:t> </a:t>
+            </a:r>
+            <a:r>
+              <a:rPr lang="en-IN" sz="1000" b="1" spc="50" dirty="0" err="1">
+                <a:ln w="0"/>
+                <a:solidFill>
+                  <a:schemeClr val="bg2"/>
+                </a:solidFill>
+                <a:effectLst>
+                  <a:innerShdw blurRad="63500" dist="50800" dir="13500000">
+                    <a:srgbClr val="000000">
+                      <a:alpha val="50000"/>
+                    </a:srgbClr>
+                  </a:innerShdw>
+                </a:effectLst>
+              </a:rPr>
+              <a:t>बर्ड</a:t>
+            </a:r>
+            <a:r>
+              <a:rPr lang="en-IN" sz="1000" b="1" spc="50" dirty="0">
+                <a:ln w="0"/>
+                <a:solidFill>
+                  <a:schemeClr val="bg2"/>
+                </a:solidFill>
+                <a:effectLst>
+                  <a:innerShdw blurRad="63500" dist="50800" dir="13500000">
+                    <a:srgbClr val="000000">
+                      <a:alpha val="50000"/>
+                    </a:srgbClr>
+                  </a:innerShdw>
+                </a:effectLst>
+              </a:rPr>
+              <a:t> </a:t>
+            </a:r>
+            <a:r>
+              <a:rPr lang="en-IN" sz="1000" b="1" spc="50" dirty="0" err="1">
+                <a:ln w="0"/>
+                <a:solidFill>
+                  <a:schemeClr val="bg2"/>
+                </a:solidFill>
+                <a:effectLst>
+                  <a:innerShdw blurRad="63500" dist="50800" dir="13500000">
+                    <a:srgbClr val="000000">
+                      <a:alpha val="50000"/>
+                    </a:srgbClr>
+                  </a:innerShdw>
+                </a:effectLst>
+              </a:rPr>
+              <a:t>फ़्लू</a:t>
+            </a:r>
+            <a:r>
+              <a:rPr lang="en-IN" sz="1000" b="1" spc="50" dirty="0">
+                <a:ln w="0"/>
+                <a:solidFill>
+                  <a:schemeClr val="bg2"/>
+                </a:solidFill>
+                <a:effectLst>
+                  <a:innerShdw blurRad="63500" dist="50800" dir="13500000">
+                    <a:srgbClr val="000000">
+                      <a:alpha val="50000"/>
+                    </a:srgbClr>
+                  </a:innerShdw>
+                </a:effectLst>
+              </a:rPr>
+              <a:t> एच5एन1 </a:t>
+            </a:r>
+            <a:r>
+              <a:rPr lang="en-IN" sz="1000" b="1" spc="50" dirty="0" err="1">
+                <a:ln w="0"/>
+                <a:solidFill>
+                  <a:schemeClr val="bg2"/>
+                </a:solidFill>
+                <a:effectLst>
+                  <a:innerShdw blurRad="63500" dist="50800" dir="13500000">
+                    <a:srgbClr val="000000">
+                      <a:alpha val="50000"/>
+                    </a:srgbClr>
+                  </a:innerShdw>
+                </a:effectLst>
+              </a:rPr>
+              <a:t>वायरस</a:t>
+            </a:r>
+            <a:r>
+              <a:rPr lang="en-IN" sz="1000" b="1" spc="50" dirty="0">
+                <a:ln w="0"/>
+                <a:solidFill>
+                  <a:schemeClr val="bg2"/>
+                </a:solidFill>
+                <a:effectLst>
+                  <a:innerShdw blurRad="63500" dist="50800" dir="13500000">
+                    <a:srgbClr val="000000">
+                      <a:alpha val="50000"/>
+                    </a:srgbClr>
+                  </a:innerShdw>
+                </a:effectLst>
+              </a:rPr>
+              <a:t> </a:t>
+            </a:r>
+            <a:r>
+              <a:rPr lang="en-IN" sz="1000" b="1" spc="50" dirty="0" err="1">
+                <a:ln w="0"/>
+                <a:solidFill>
+                  <a:schemeClr val="bg2"/>
+                </a:solidFill>
+                <a:effectLst>
+                  <a:innerShdw blurRad="63500" dist="50800" dir="13500000">
+                    <a:srgbClr val="000000">
+                      <a:alpha val="50000"/>
+                    </a:srgbClr>
+                  </a:innerShdw>
+                </a:effectLst>
+              </a:rPr>
+              <a:t>अमरीकी</a:t>
+            </a:r>
+            <a:r>
+              <a:rPr lang="en-IN" sz="1000" b="1" spc="50" dirty="0">
+                <a:ln w="0"/>
+                <a:solidFill>
+                  <a:schemeClr val="bg2"/>
+                </a:solidFill>
+                <a:effectLst>
+                  <a:innerShdw blurRad="63500" dist="50800" dir="13500000">
+                    <a:srgbClr val="000000">
+                      <a:alpha val="50000"/>
+                    </a:srgbClr>
+                  </a:innerShdw>
+                </a:effectLst>
+              </a:rPr>
+              <a:t> </a:t>
+            </a:r>
+            <a:r>
+              <a:rPr lang="en-IN" sz="1000" b="1" spc="50" dirty="0" err="1">
+                <a:ln w="0"/>
+                <a:solidFill>
+                  <a:schemeClr val="bg2"/>
+                </a:solidFill>
+                <a:effectLst>
+                  <a:innerShdw blurRad="63500" dist="50800" dir="13500000">
+                    <a:srgbClr val="000000">
+                      <a:alpha val="50000"/>
+                    </a:srgbClr>
+                  </a:innerShdw>
+                </a:effectLst>
+              </a:rPr>
+              <a:t>वैज्ञानिकों</a:t>
+            </a:r>
+            <a:r>
+              <a:rPr lang="en-IN" sz="1000" b="1" spc="50" dirty="0">
+                <a:ln w="0"/>
+                <a:solidFill>
+                  <a:schemeClr val="bg2"/>
+                </a:solidFill>
+                <a:effectLst>
+                  <a:innerShdw blurRad="63500" dist="50800" dir="13500000">
+                    <a:srgbClr val="000000">
+                      <a:alpha val="50000"/>
+                    </a:srgbClr>
+                  </a:innerShdw>
+                </a:effectLst>
+              </a:rPr>
+              <a:t> </a:t>
+            </a:r>
+            <a:r>
+              <a:rPr lang="en-IN" sz="1000" b="1" spc="50" dirty="0" err="1">
+                <a:ln w="0"/>
+                <a:solidFill>
+                  <a:schemeClr val="bg2"/>
+                </a:solidFill>
+                <a:effectLst>
+                  <a:innerShdw blurRad="63500" dist="50800" dir="13500000">
+                    <a:srgbClr val="000000">
+                      <a:alpha val="50000"/>
+                    </a:srgbClr>
+                  </a:innerShdw>
+                </a:effectLst>
+              </a:rPr>
+              <a:t>ने</a:t>
+            </a:r>
+            <a:r>
+              <a:rPr lang="en-IN" sz="1000" b="1" spc="50" dirty="0">
+                <a:ln w="0"/>
+                <a:solidFill>
+                  <a:schemeClr val="bg2"/>
+                </a:solidFill>
+                <a:effectLst>
+                  <a:innerShdw blurRad="63500" dist="50800" dir="13500000">
+                    <a:srgbClr val="000000">
+                      <a:alpha val="50000"/>
+                    </a:srgbClr>
+                  </a:innerShdw>
+                </a:effectLst>
+              </a:rPr>
+              <a:t> </a:t>
+            </a:r>
+            <a:r>
+              <a:rPr lang="en-IN" sz="1000" b="1" spc="50" dirty="0" err="1">
+                <a:ln w="0"/>
+                <a:solidFill>
+                  <a:schemeClr val="bg2"/>
+                </a:solidFill>
+                <a:effectLst>
+                  <a:innerShdw blurRad="63500" dist="50800" dir="13500000">
+                    <a:srgbClr val="000000">
+                      <a:alpha val="50000"/>
+                    </a:srgbClr>
+                  </a:innerShdw>
+                </a:effectLst>
+              </a:rPr>
+              <a:t>पुष्टि</a:t>
+            </a:r>
+            <a:r>
+              <a:rPr lang="en-IN" sz="1000" b="1" spc="50" dirty="0">
+                <a:ln w="0"/>
+                <a:solidFill>
+                  <a:schemeClr val="bg2"/>
+                </a:solidFill>
+                <a:effectLst>
+                  <a:innerShdw blurRad="63500" dist="50800" dir="13500000">
+                    <a:srgbClr val="000000">
+                      <a:alpha val="50000"/>
+                    </a:srgbClr>
+                  </a:innerShdw>
+                </a:effectLst>
+              </a:rPr>
+              <a:t> </a:t>
+            </a:r>
+            <a:r>
+              <a:rPr lang="en-IN" sz="1000" b="1" spc="50" dirty="0" err="1">
+                <a:ln w="0"/>
+                <a:solidFill>
+                  <a:schemeClr val="bg2"/>
+                </a:solidFill>
+                <a:effectLst>
+                  <a:innerShdw blurRad="63500" dist="50800" dir="13500000">
+                    <a:srgbClr val="000000">
+                      <a:alpha val="50000"/>
+                    </a:srgbClr>
+                  </a:innerShdw>
+                </a:effectLst>
+              </a:rPr>
+              <a:t>की</a:t>
+            </a:r>
+            <a:r>
+              <a:rPr lang="en-IN" sz="1000" b="1" spc="50" dirty="0">
+                <a:ln w="0"/>
+                <a:solidFill>
+                  <a:schemeClr val="bg2"/>
+                </a:solidFill>
+                <a:effectLst>
+                  <a:innerShdw blurRad="63500" dist="50800" dir="13500000">
+                    <a:srgbClr val="000000">
+                      <a:alpha val="50000"/>
+                    </a:srgbClr>
+                  </a:innerShdw>
+                </a:effectLst>
+              </a:rPr>
+              <a:t> एच5एन1 </a:t>
+            </a:r>
+            <a:r>
+              <a:rPr lang="en-IN" sz="1000" b="1" spc="50" dirty="0" err="1">
+                <a:ln w="0"/>
+                <a:solidFill>
+                  <a:schemeClr val="bg2"/>
+                </a:solidFill>
+                <a:effectLst>
+                  <a:innerShdw blurRad="63500" dist="50800" dir="13500000">
+                    <a:srgbClr val="000000">
+                      <a:alpha val="50000"/>
+                    </a:srgbClr>
+                  </a:innerShdw>
+                </a:effectLst>
+              </a:rPr>
+              <a:t>वायरस</a:t>
+            </a:r>
+            <a:r>
+              <a:rPr lang="en-IN" sz="1000" b="1" spc="50" dirty="0">
+                <a:ln w="0"/>
+                <a:solidFill>
+                  <a:schemeClr val="bg2"/>
+                </a:solidFill>
+                <a:effectLst>
+                  <a:innerShdw blurRad="63500" dist="50800" dir="13500000">
+                    <a:srgbClr val="000000">
+                      <a:alpha val="50000"/>
+                    </a:srgbClr>
+                  </a:innerShdw>
+                </a:effectLst>
+              </a:rPr>
+              <a:t> </a:t>
+            </a:r>
+            <a:r>
+              <a:rPr lang="en-IN" sz="1000" b="1" spc="50" dirty="0" err="1">
+                <a:ln w="0"/>
+                <a:solidFill>
+                  <a:schemeClr val="bg2"/>
+                </a:solidFill>
+                <a:effectLst>
+                  <a:innerShdw blurRad="63500" dist="50800" dir="13500000">
+                    <a:srgbClr val="000000">
+                      <a:alpha val="50000"/>
+                    </a:srgbClr>
+                  </a:innerShdw>
+                </a:effectLst>
+              </a:rPr>
+              <a:t>दो</a:t>
+            </a:r>
+            <a:r>
+              <a:rPr lang="en-IN" sz="1000" b="1" spc="50" dirty="0">
+                <a:ln w="0"/>
+                <a:solidFill>
+                  <a:schemeClr val="bg2"/>
+                </a:solidFill>
+                <a:effectLst>
+                  <a:innerShdw blurRad="63500" dist="50800" dir="13500000">
+                    <a:srgbClr val="000000">
+                      <a:alpha val="50000"/>
+                    </a:srgbClr>
+                  </a:innerShdw>
+                </a:effectLst>
+              </a:rPr>
+              <a:t> </a:t>
+            </a:r>
+            <a:r>
+              <a:rPr lang="en-IN" sz="1000" b="1" spc="50" dirty="0" err="1">
+                <a:ln w="0"/>
+                <a:solidFill>
+                  <a:schemeClr val="bg2"/>
+                </a:solidFill>
+                <a:effectLst>
+                  <a:innerShdw blurRad="63500" dist="50800" dir="13500000">
+                    <a:srgbClr val="000000">
+                      <a:alpha val="50000"/>
+                    </a:srgbClr>
+                  </a:innerShdw>
+                </a:effectLst>
+              </a:rPr>
+              <a:t>विषाणुओं</a:t>
+            </a:r>
+            <a:r>
+              <a:rPr lang="en-IN" sz="1000" b="1" spc="50" dirty="0">
+                <a:ln w="0"/>
+                <a:solidFill>
+                  <a:schemeClr val="bg2"/>
+                </a:solidFill>
+                <a:effectLst>
+                  <a:innerShdw blurRad="63500" dist="50800" dir="13500000">
+                    <a:srgbClr val="000000">
+                      <a:alpha val="50000"/>
+                    </a:srgbClr>
+                  </a:innerShdw>
+                </a:effectLst>
+              </a:rPr>
+              <a:t> </a:t>
+            </a:r>
+            <a:r>
+              <a:rPr lang="en-IN" sz="1000" b="1" spc="50" dirty="0" err="1">
+                <a:ln w="0"/>
+                <a:solidFill>
+                  <a:schemeClr val="bg2"/>
+                </a:solidFill>
+                <a:effectLst>
+                  <a:innerShdw blurRad="63500" dist="50800" dir="13500000">
+                    <a:srgbClr val="000000">
+                      <a:alpha val="50000"/>
+                    </a:srgbClr>
+                  </a:innerShdw>
+                </a:effectLst>
+              </a:rPr>
+              <a:t>बदल</a:t>
+            </a:r>
+            <a:r>
+              <a:rPr lang="en-IN" sz="1000" b="1" spc="50" dirty="0">
+                <a:ln w="0"/>
+                <a:solidFill>
+                  <a:schemeClr val="bg2"/>
+                </a:solidFill>
+                <a:effectLst>
+                  <a:innerShdw blurRad="63500" dist="50800" dir="13500000">
+                    <a:srgbClr val="000000">
+                      <a:alpha val="50000"/>
+                    </a:srgbClr>
+                  </a:innerShdw>
+                </a:effectLst>
+              </a:rPr>
+              <a:t> </a:t>
+            </a:r>
+            <a:r>
+              <a:rPr lang="en-IN" sz="1000" b="1" spc="50" dirty="0" err="1">
+                <a:ln w="0"/>
+                <a:solidFill>
+                  <a:schemeClr val="bg2"/>
+                </a:solidFill>
+                <a:effectLst>
+                  <a:innerShdw blurRad="63500" dist="50800" dir="13500000">
+                    <a:srgbClr val="000000">
+                      <a:alpha val="50000"/>
+                    </a:srgbClr>
+                  </a:innerShdw>
+                </a:effectLst>
+              </a:rPr>
+              <a:t>चुका</a:t>
+            </a:r>
+            <a:r>
+              <a:rPr lang="en-IN" sz="1000" b="1" spc="50" dirty="0">
+                <a:ln w="0"/>
+                <a:solidFill>
+                  <a:schemeClr val="bg2"/>
+                </a:solidFill>
+                <a:effectLst>
+                  <a:innerShdw blurRad="63500" dist="50800" dir="13500000">
+                    <a:srgbClr val="000000">
+                      <a:alpha val="50000"/>
+                    </a:srgbClr>
+                  </a:innerShdw>
+                </a:effectLst>
+              </a:rPr>
+              <a:t> </a:t>
+            </a:r>
+            <a:r>
+              <a:rPr lang="en-IN" sz="1000" b="1" spc="50" dirty="0" err="1">
+                <a:ln w="0"/>
+                <a:solidFill>
+                  <a:schemeClr val="bg2"/>
+                </a:solidFill>
+                <a:effectLst>
+                  <a:innerShdw blurRad="63500" dist="50800" dir="13500000">
+                    <a:srgbClr val="000000">
+                      <a:alpha val="50000"/>
+                    </a:srgbClr>
+                  </a:innerShdw>
+                </a:effectLst>
+              </a:rPr>
+              <a:t>मनुष्यों</a:t>
+            </a:r>
+            <a:r>
+              <a:rPr lang="en-IN" sz="1000" b="1" spc="50" dirty="0">
+                <a:ln w="0"/>
+                <a:solidFill>
+                  <a:schemeClr val="bg2"/>
+                </a:solidFill>
+                <a:effectLst>
+                  <a:innerShdw blurRad="63500" dist="50800" dir="13500000">
+                    <a:srgbClr val="000000">
+                      <a:alpha val="50000"/>
+                    </a:srgbClr>
+                  </a:innerShdw>
+                </a:effectLst>
+              </a:rPr>
+              <a:t> </a:t>
+            </a:r>
+            <a:r>
+              <a:rPr lang="en-IN" sz="1000" b="1" spc="50" dirty="0" err="1">
+                <a:ln w="0"/>
+                <a:solidFill>
+                  <a:schemeClr val="bg2"/>
+                </a:solidFill>
+                <a:effectLst>
+                  <a:innerShdw blurRad="63500" dist="50800" dir="13500000">
+                    <a:srgbClr val="000000">
+                      <a:alpha val="50000"/>
+                    </a:srgbClr>
+                  </a:innerShdw>
+                </a:effectLst>
+              </a:rPr>
+              <a:t>खतरा</a:t>
+            </a:r>
+            <a:r>
+              <a:rPr lang="en-IN" sz="1000" b="1" spc="50" dirty="0">
+                <a:ln w="0"/>
+                <a:solidFill>
+                  <a:schemeClr val="bg2"/>
+                </a:solidFill>
+                <a:effectLst>
+                  <a:innerShdw blurRad="63500" dist="50800" dir="13500000">
+                    <a:srgbClr val="000000">
+                      <a:alpha val="50000"/>
+                    </a:srgbClr>
+                  </a:innerShdw>
+                </a:effectLst>
+              </a:rPr>
+              <a:t> </a:t>
+            </a:r>
+            <a:r>
+              <a:rPr lang="en-IN" sz="1000" b="1" spc="50" dirty="0" err="1">
+                <a:ln w="0"/>
+                <a:solidFill>
+                  <a:schemeClr val="bg2"/>
+                </a:solidFill>
+                <a:effectLst>
+                  <a:innerShdw blurRad="63500" dist="50800" dir="13500000">
+                    <a:srgbClr val="000000">
+                      <a:alpha val="50000"/>
+                    </a:srgbClr>
+                  </a:innerShdw>
+                </a:effectLst>
+              </a:rPr>
+              <a:t>बढ़</a:t>
+            </a:r>
+            <a:r>
+              <a:rPr lang="en-IN" sz="1000" b="1" spc="50" dirty="0">
+                <a:ln w="0"/>
+                <a:solidFill>
+                  <a:schemeClr val="bg2"/>
+                </a:solidFill>
+                <a:effectLst>
+                  <a:innerShdw blurRad="63500" dist="50800" dir="13500000">
+                    <a:srgbClr val="000000">
+                      <a:alpha val="50000"/>
+                    </a:srgbClr>
+                  </a:innerShdw>
+                </a:effectLst>
+              </a:rPr>
+              <a:t> </a:t>
+            </a:r>
+            <a:r>
+              <a:rPr lang="en-IN" sz="1000" b="1" spc="50" dirty="0" err="1">
+                <a:ln w="0"/>
+                <a:solidFill>
+                  <a:schemeClr val="bg2"/>
+                </a:solidFill>
+                <a:effectLst>
+                  <a:innerShdw blurRad="63500" dist="50800" dir="13500000">
+                    <a:srgbClr val="000000">
+                      <a:alpha val="50000"/>
+                    </a:srgbClr>
+                  </a:innerShdw>
+                </a:effectLst>
+              </a:rPr>
+              <a:t>गया</a:t>
+            </a:r>
+            <a:endParaRPr lang="en-US" sz="1000" dirty="0"/>
           </a:p>
         </p:txBody>
       </p:sp>
@@ -10571,28 +13973,6 @@
               </a:lnSpc>
               <a:buNone/>
             </a:pPr>
-            <a:r>
-              <a:rPr lang="en-US" sz="1300" b="1" dirty="0">
-                <a:solidFill>
-                  <a:srgbClr val="1E2761"/>
-                </a:solidFill>
-                <a:latin typeface="Calibri" pitchFamily="34" charset="0"/>
-                <a:ea typeface="Calibri" pitchFamily="34" charset="-122"/>
-                <a:cs typeface="Calibri" pitchFamily="34" charset="-120"/>
-              </a:rPr>
-              <a:t>~42.5% token reduction  </a:t>
-            </a:r>
-            <a:r>
-              <a:rPr lang="en-US" sz="1050" dirty="0">
-                <a:solidFill>
-                  <a:srgbClr val="5A6B87"/>
-                </a:solidFill>
-                <a:latin typeface="Calibri" pitchFamily="34" charset="0"/>
-                <a:ea typeface="Calibri" pitchFamily="34" charset="-122"/>
-                <a:cs typeface="Calibri" pitchFamily="34" charset="-120"/>
-              </a:rPr>
-              <a:t>— key entities and the answer-bearing facts are fully retained.</a:t>
-            </a:r>
             <a:endParaRPr lang="en-US" sz="1300" dirty="0"/>
           </a:p>
         </p:txBody>

</xml_diff>